<commit_message>
chore: TCC — documentos por etapa enxutos e só com dados do sistema; backlog com resumo de todas as tarefas
</commit_message>
<xml_diff>
--- a/apresentacao-orientador/apresentacao-principal.pptx
+++ b/apresentacao-orientador/apresentacao-principal.pptx
@@ -125,26 +125,26 @@
   <p:extLst>
     <p:ext uri="{521415D9-36F7-43E2-AB2F-B90AF26B5E84}">
       <p14:sectionLst xmlns:p14="http://schemas.microsoft.com/office/powerpoint/2010/main">
-        <p14:section name="Abertura" id="{0c5b29d7-8caf-de59-0199-4e3839064bfd}">
+        <p14:section name="Abertura" id="{2dcd893e-a3ed-cca2-8a45-d64aaeae2860}">
           <p14:sldIdLst>
             <p14:sldId id="256"/>
             <p14:sldId id="257"/>
             <p14:sldId id="258"/>
           </p14:sldIdLst>
         </p14:section>
-        <p14:section name="O plano" id="{1f714f10-0cae-eea2-fdd1-827b3d159f10}">
+        <p14:section name="O plano" id="{482b4307-1b20-d5e0-1ad6-1b86bb4c8c96}">
           <p14:sldIdLst>
             <p14:sldId id="259"/>
             <p14:sldId id="260"/>
           </p14:sldIdLst>
         </p14:section>
-        <p14:section name="Panorama" id="{509d1642-0444-8a89-07d7-90b580b3394e}">
+        <p14:section name="Panorama" id="{7020ea89-be43-44ff-592f-d0777f9d6540}">
           <p14:sldIdLst>
             <p14:sldId id="261"/>
             <p14:sldId id="262"/>
           </p14:sldIdLst>
         </p14:section>
-        <p14:section name="Etapas" id="{45b497d9-9432-73ee-9113-9c174e35f6a8}">
+        <p14:section name="Etapas" id="{817405c5-32cb-9a42-1438-8b95bf916235}">
           <p14:sldIdLst>
             <p14:sldId id="263"/>
             <p14:sldId id="264"/>
@@ -155,14 +155,14 @@
             <p14:sldId id="269"/>
           </p14:sldIdLst>
         </p14:section>
-        <p14:section name="Dados" id="{4712a1e1-3064-e842-17a2-5afa3a357d43}">
+        <p14:section name="Dados" id="{fac1f983-0189-a503-e2b5-45cf222e2149}">
           <p14:sldIdLst>
             <p14:sldId id="270"/>
             <p14:sldId id="271"/>
             <p14:sldId id="272"/>
           </p14:sldIdLst>
         </p14:section>
-        <p14:section name="Próximos passos" id="{26087a08-4cd1-bf7c-bde6-44feaa22fcea}">
+        <p14:section name="Próximos passos" id="{1fd0b11c-75a1-a79c-bafa-668c9296864c}">
           <p14:sldIdLst>
             <p14:sldId id="273"/>
             <p14:sldId id="274"/>
@@ -755,7 +755,7 @@
                 </a:solidFill>
                 <a:latin typeface="+mn-lt"/>
               </a:rPr>
-              <a:t>Execuções de agente por item (limite: 2)</a:t>
+              <a:t>Tarefas concluídas</a:t>
             </a:r>
           </a:p>
         </c:rich>
@@ -779,20 +779,20 @@
               <c:strCache>
                 <c:ptCount val="1"/>
                 <c:pt idx="0">
-                  <c:v>Execuções</c:v>
+                  <c:v>Tarefas</c:v>
                 </c:pt>
               </c:strCache>
             </c:strRef>
           </c:tx>
           <c:spPr>
             <a:solidFill>
-              <a:srgbClr val="E9A23B"/>
+              <a:srgbClr val="2A9D8F"/>
             </a:solidFill>
             <a:effectLst/>
           </c:spPr>
           <c:invertIfNegative val="0"/>
           <c:dLbls>
-            <c:numFmt formatCode="0.00" sourceLinked="0"/>
+            <c:numFmt formatCode="0" sourceLinked="0"/>
             <c:txPr>
               <a:bodyPr/>
               <a:lstStyle/>
@@ -850,29 +850,29 @@
                 <c:formatCode>General</c:formatCode>
                 <c:ptCount val="6"/>
                 <c:pt idx="0">
-                  <c:v>1</c:v>
+                  <c:v>5</c:v>
                 </c:pt>
                 <c:pt idx="1">
-                  <c:v>1.17</c:v>
+                  <c:v>6</c:v>
                 </c:pt>
                 <c:pt idx="2">
-                  <c:v>1</c:v>
+                  <c:v>8</c:v>
                 </c:pt>
                 <c:pt idx="3">
-                  <c:v>1.67</c:v>
+                  <c:v>6</c:v>
                 </c:pt>
                 <c:pt idx="4">
-                  <c:v>1.62</c:v>
+                  <c:v>5</c:v>
                 </c:pt>
                 <c:pt idx="5">
-                  <c:v>1.5</c:v>
+                  <c:v>7</c:v>
                 </c:pt>
               </c:numCache>
             </c:numRef>
           </c:val>
         </c:ser>
         <c:dLbls>
-          <c:numFmt formatCode="0.00" sourceLinked="0"/>
+          <c:numFmt formatCode="0" sourceLinked="0"/>
           <c:txPr>
             <a:bodyPr/>
             <a:lstStyle/>
@@ -1031,7 +1031,7 @@
                 </a:solidFill>
                 <a:latin typeface="+mn-lt"/>
               </a:rPr>
-              <a:t>Commits por etapa</a:t>
+              <a:t>Commits na branch da etapa</a:t>
             </a:r>
           </a:p>
         </c:rich>
@@ -9489,7 +9489,7 @@
                 <a:ea typeface="Cambria" pitchFamily="34" charset="-122"/>
                 <a:cs typeface="Cambria" pitchFamily="34" charset="-120"/>
               </a:rPr>
-              <a:t>Retrabalho por etapa e commits entregues</a:t>
+              <a:t>Entregas por etapa: tarefas e commits</a:t>
             </a:r>
             <a:endParaRPr lang="en-US" sz="2800" dirty="0"/>
           </a:p>
@@ -9560,7 +9560,7 @@
                 <a:ea typeface="Calibri" pitchFamily="34" charset="-122"/>
                 <a:cs typeface="Calibri" pitchFamily="34" charset="-120"/>
               </a:rPr>
-              <a:t>Execuções: quantas vezes um agente precisou construir cada item até ele ser aprovado pelos dois portões. O critério de desempenho “pouco retrabalho” pede média de até 2.</a:t>
+              <a:t>Cada tarefa corresponde a um pacote do plano; cada commit entrega um passo de uma tarefa, sempre com a verificação completa verde.</a:t>
             </a:r>
             <a:endParaRPr lang="en-US" sz="1100" dirty="0"/>
           </a:p>

</xml_diff>

<commit_message>
tcc: relatorios Word E1-E7 e apresentacao principal regerados
Saida do gerador dos commits anteriores. Sai a copia 'E2-fundacao (NOVA - para aprovar).docx': a proposta foi aprovada e virou o E2-fundacao.docx. A apresentacao principal reflete a recontagem dos requisitos (8 atendidos, 6 parciais, 1 pendente).
</commit_message>
<xml_diff>
--- a/apresentacao-orientador/apresentacao-principal.pptx
+++ b/apresentacao-orientador/apresentacao-principal.pptx
@@ -125,26 +125,26 @@
   <p:extLst>
     <p:ext uri="{521415D9-36F7-43E2-AB2F-B90AF26B5E84}">
       <p14:sectionLst xmlns:p14="http://schemas.microsoft.com/office/powerpoint/2010/main">
-        <p14:section name="Abertura" id="{2dcd893e-a3ed-cca2-8a45-d64aaeae2860}">
+        <p14:section name="Abertura" id="{f059e4ba-a518-62bd-306a-bf7d44a94460}">
           <p14:sldIdLst>
             <p14:sldId id="256"/>
             <p14:sldId id="257"/>
             <p14:sldId id="258"/>
           </p14:sldIdLst>
         </p14:section>
-        <p14:section name="O plano" id="{482b4307-1b20-d5e0-1ad6-1b86bb4c8c96}">
+        <p14:section name="O plano" id="{bce015fe-69b7-8e80-2e2d-9f8e85089be9}">
           <p14:sldIdLst>
             <p14:sldId id="259"/>
             <p14:sldId id="260"/>
           </p14:sldIdLst>
         </p14:section>
-        <p14:section name="Panorama" id="{7020ea89-be43-44ff-592f-d0777f9d6540}">
+        <p14:section name="Panorama" id="{a3486d38-e381-6e97-c23b-4847da460564}">
           <p14:sldIdLst>
             <p14:sldId id="261"/>
             <p14:sldId id="262"/>
           </p14:sldIdLst>
         </p14:section>
-        <p14:section name="Etapas" id="{817405c5-32cb-9a42-1438-8b95bf916235}">
+        <p14:section name="Etapas" id="{623d9e8b-73fb-8898-9e33-5d76386ebdcd}">
           <p14:sldIdLst>
             <p14:sldId id="263"/>
             <p14:sldId id="264"/>
@@ -155,14 +155,14 @@
             <p14:sldId id="269"/>
           </p14:sldIdLst>
         </p14:section>
-        <p14:section name="Dados" id="{fac1f983-0189-a503-e2b5-45cf222e2149}">
+        <p14:section name="Dados" id="{f3b753bb-3d4b-5ad4-2424-2e4839bf3fd4}">
           <p14:sldIdLst>
             <p14:sldId id="270"/>
             <p14:sldId id="271"/>
             <p14:sldId id="272"/>
           </p14:sldIdLst>
         </p14:section>
-        <p14:section name="Próximos passos" id="{1fd0b11c-75a1-a79c-bafa-668c9296864c}">
+        <p14:section name="Próximos passos" id="{1a510515-c44a-a223-d165-7d479dc48fcb}">
           <p14:sldIdLst>
             <p14:sldId id="273"/>
             <p14:sldId id="274"/>
@@ -1855,9 +1855,9 @@
           <a:p>
             <a:r>
               <a:rPr lang="en-US" dirty="0"/>
-              <a:t>A linha de produção funciona de ponta a ponta: uma tarefa criada do zero é reprovada de propósito, sobe de modelo, é refeita e conclui.
+              <a:t>As regras da linha de produção estão prontas e provadas: uma tarefa é reprovada de propósito, sobe de modelo, é refeita e conclui — cada passo gravado numa transação.
 Como: Máquina de estados pura + transição transacional: estado, relatório e custo numa única transação (R2). Fila por dependências, desempate pela tarefa que destrava mais; especialista soma ao papel. Critérios de aceite são comandos rodados pelo sistema, com lista de binários permitidos. Dois portões independentes; o revisor não recebe ferramenta de escrita (R3). Escada de resposta: modelo mais forte, outro especialista, replanejar, humano (R4, R5); teto de gasto que nunca corta no meio (R14).
-Pendente: R1 (pedido → tarefas) está implementado; o teste com um pedido real de ponta a ponta acontece na validação (E8).
+Pendente: R1 (pedido → tarefas) está implementado; o teste com um pedido real de ponta a ponta acontece na validação (E8). Escada de resposta, diagnóstico e teto de gasto são regras puras, prontas e testadas; nesta etapa nenhum laço automático ainda as chama — quem as encadeia é o teste do marco.
 Próxima: E5 — paralelismo e tolerância a falhas.</a:t>
             </a:r>
             <a:endParaRPr lang="en-US" dirty="0"/>
@@ -1947,8 +1947,8 @@
             <a:r>
               <a:rPr lang="en-US" dirty="0"/>
               <a:t>Três tarefas rodam em paralelo; matar uma no meio não afeta as outras, e ela volta à fila sem perder trabalho.
-Como: Um processo supervisionado por tarefa, com registro dos agentes em voo (R13). Fila durável no banco (Oban): enfileirar e mudar o estado da tarefa na mesma transação. As áreas de cada tarefa são exclusão mútua; o número em voo segue o perfil de 8 GB (R6, R9). Parede de cota do fornecedor reconhecida: o sistema dorme até a reabertura e rearma sozinho. Na subida após uma queda, o trabalho parcial é commitado em nome da tarefa certa.
-Pendente: nada.
+Como: Um processo supervisionado por tarefa, com registro dos agentes em voo (R13). Fila durável no banco (Oban): enfileirar e mudar o estado da tarefa na mesma transação. As áreas de cada tarefa são exclusão mútua; o número em voo segue o perfil de 8 GB (R6, R9). Parede de cota do fornecedor reconhecida: o sistema dorme até a reabertura e rearma sozinho. Depois de uma queda, o saneamento devolve o estado das tarefas órfãs e commita o trabalho parcial em nome da tarefa certa (R13).
+Pendente: Nesta etapa o lote e o saneamento são chamados pelo teste do marco; quem monta a rodada e enfileira sozinho é o piloto automático (E7). O saneamento roda quando chamado, ainda não automaticamente na subida do sistema. Medir o pico de memória com agentes em paralelo na máquina de 8 GB (R9).
 Próxima: E6 — memória do projeto.</a:t>
             </a:r>
             <a:endParaRPr lang="en-US" dirty="0"/>
@@ -2038,9 +2038,9 @@
             <a:r>
               <a:rPr lang="en-US" dirty="0"/>
               <a:t>As peças da memória estão construídas e testadas; a entrega da etapa (o agente citar a decisão anterior) ainda não foi demonstrada.
-Como: Medição antes da escolha: o modelo de embedding local escolhido por desempenho medido (R9). Cada commit do projeto vira trechos com embedding, sem duplicar em reingestão. Busca híbrida (significado + termo exato) com fusão de postos, filtrada por projeto. Bloco de contexto com a fonte de cada trecho, fora da faixa cacheada do prompt (R7). Avaliação com recall@8, recall@1 e MRR; busca abaixo da linha de base desliga o bloco.
-Pendente: Marco bloqueado: a fila ainda monta a mensagem do agente sem o bloco de memória (ajuste pequeno, já diagnosticado).
-Próxima: Fechar o ajuste da fila e demonstrar o agente real citando a decisão anterior.</a:t>
+Como: Medição antes da escolha: o modelo de embedding local escolhido por desempenho medido (R9). O histórico do projeto vira trechos por seção, com embedding; reingerir o mesmo conteúdo não duplica nada. Busca híbrida (significado + termo exato) com fusão de postos, filtrada por projeto. Bloco de contexto com a fonte de cada trecho, fora da faixa cacheada do prompt (R7). Avaliação com recall@8, recall@1 e MRR; busca abaixo da linha de base desliga o bloco.
+Pendente: Marco bloqueado: nesta etapa a memória ainda não está ligada ao despacho; na E7 o despacho passa a anexar o bloco, mas a fila ainda o descarta ao montar a mensagem (ajuste pequeno, já localizado). A ingestão ainda não é disparada sozinha a cada mudança do histórico; nesta etapa quem a chama são os testes. Medir o pico de memória com agentes em paralelo na máquina de 8 GB (R9).
+Próxima: E7 — painel ao vivo e piloto automático; o despacho passa a anexar a memória (falta a fila entregá-la ao agente).</a:t>
             </a:r>
             <a:endParaRPr lang="en-US" dirty="0"/>
           </a:p>
@@ -2128,9 +2128,9 @@
           <a:p>
             <a:r>
               <a:rPr lang="en-US" dirty="0"/>
-              <a:t>Tela ao vivo, parar/retomar, piloto automático com teto de gasto e o agente real ligado à fila estão prontos; o projeto inteiro sem intervenção ainda não foi executado.
-Como: Barramento de eventos e telemetria por despacho; a tela lê os mesmos eventos do motor. Quadro de tarefas por estado e console do agente ao vivo, com o custo acumulado (R8). Piloto automático: decisão como função pura, tetos obrigatórios, dorme na cota em vez de parar. Trilha para entregas que não são código, com grau de prova obrigatório em cada critério. Varredura de segredos antes de publicar; doutrina própria para construtor, verificador e revisor.
-Pendente: Marco final (um projeto inteiro sem intervenção) depende do ajuste da E6 e da autorização do teto de gasto.
+              <a:t>Telas ao vivo, parar/retomar, piloto com dois freios, trilha genérica, busca de segredos e o agente real na fila estão prontos e testados; parte ainda não está ligada ao sistema em execução, e o projeto inteiro ainda não foi executado.
+Como: Barramento de eventos: o motor avisa início e fim de despacho e a parede de cota; telas e piloto escutam sem tocar no motor. Quadro de tarefas por estado, com o custo de cada tarefa, e console com os agentes em execução e a cota (R8). Piloto automático: decisão como função pura em ordem fixa, dois freios obrigatórios, dorme na cota em vez de parar. Trilha para entregas que não são código, com grau de prova obrigatório em cada critério; busca de segredos que recusa publicar. O agente real na fila: mensagem montada da tarefa e da doutrina do papel, ferramentas presas às áreas, portão por papel.
+Pendente: Ligar os eventos de mudança de estado e de volta: o motor ainda não os emite, então a tela os recebe só nos testes. Colocar numa página os componentes de Parar/Retomar e do piloto (prontos e testados, sem tela que os use). Chamar no caminho real a trilha genérica, os graus de prova e a busca de segredos (prontos e testados, sem chamador). A fila enviar o bloco de memória ao agente (destrava o marco da E6). Executar o marco: um projeto inteiro sem intervenção, com teto de gasto autorizado.
 Próxima: E8 — validação com os cinco projetos de teste e a primeira medição dos 8 critérios.</a:t>
             </a:r>
             <a:endParaRPr lang="en-US" dirty="0"/>
@@ -6122,7 +6122,7 @@
                 <a:ea typeface="Calibri" pitchFamily="34" charset="-122"/>
                 <a:cs typeface="Calibri" pitchFamily="34" charset="-120"/>
               </a:rPr>
-              <a:t>mix test test/factory/milestone_e4_test.exs — histórico com os seis estados, reprovação por entrega errada, modelo sobe no 2º ciclo, custo por ciclo separado.</a:t>
+              <a:t>mix test test/factory/milestone_e4_test.exs — histórico pronta → execução → teste → execução → teste → revisão → concluída, reprovação por entrega errada, modelo sobe no 2º ciclo, custo por ciclo separado.</a:t>
             </a:r>
             <a:endParaRPr lang="en-US" sz="950" dirty="0"/>
           </a:p>
@@ -7644,7 +7644,7 @@
                 <a:ea typeface="Calibri" pitchFamily="34" charset="-122"/>
                 <a:cs typeface="Calibri" pitchFamily="34" charset="-120"/>
               </a:rPr>
-              <a:t>Guardar o histórico a cada alteração</a:t>
+              <a:t>Guardar o histórico em trechos consultáveis</a:t>
             </a:r>
             <a:endParaRPr lang="en-US" sz="1150" dirty="0"/>
           </a:p>
@@ -8112,7 +8112,7 @@
                 <a:ea typeface="Calibri" pitchFamily="34" charset="-122"/>
                 <a:cs typeface="Calibri" pitchFamily="34" charset="-120"/>
               </a:rPr>
-              <a:t>mix test test/factory/memory/ — busca, contexto, ingestão e avaliação.</a:t>
+              <a:t>mix test test/factory/memory/ — ingestão, busca, bloco e avaliação  ·  mix run priv/probes/ollama_real.exs — o embedder real, sem custo</a:t>
             </a:r>
             <a:endParaRPr lang="en-US" sz="950" dirty="0"/>
           </a:p>
@@ -9235,7 +9235,7 @@
                 <a:ea typeface="Calibri" pitchFamily="34" charset="-122"/>
                 <a:cs typeface="Calibri" pitchFamily="34" charset="-120"/>
               </a:rPr>
-              <a:t>mix phx.server → /board e /console; testes em test/factory_web/ e test/factory/autopilot/.</a:t>
+              <a:t>mix test test/factory/autopilot/ test/factory_web/ test/factory/queue/; mix phx.server → /board e /console.</a:t>
             </a:r>
             <a:endParaRPr lang="en-US" sz="950" dirty="0"/>
           </a:p>
@@ -9671,7 +9671,7 @@
                 <a:ea typeface="Cambria" pitchFamily="34" charset="-122"/>
                 <a:cs typeface="Cambria" pitchFamily="34" charset="-120"/>
               </a:rPr>
-              <a:t>Requisitos: 11 atendidos, 3 parciais, 1 pendente</a:t>
+              <a:t>Requisitos: 8 atendidos, 6 parciais, 1 pendente</a:t>
             </a:r>
             <a:endParaRPr lang="en-US" sz="2800" dirty="0"/>
           </a:p>
@@ -10051,11 +10051,11 @@
             </a:avLst>
           </a:prstGeom>
           <a:solidFill>
-            <a:schemeClr val="accent2"/>
+            <a:schemeClr val="accent1"/>
           </a:solidFill>
           <a:ln w="12700">
             <a:solidFill>
-              <a:schemeClr val="accent2"/>
+              <a:schemeClr val="accent1"/>
             </a:solidFill>
             <a:prstDash val="solid"/>
           </a:ln>
@@ -10147,7 +10147,7 @@
                 <a:ea typeface="Calibri" pitchFamily="34" charset="-122"/>
                 <a:cs typeface="Calibri" pitchFamily="34" charset="-120"/>
               </a:rPr>
-              <a:t>  escada de resposta</a:t>
+              <a:t>  escada pronta e testada; o laço automático ainda não a chama</a:t>
             </a:r>
             <a:endParaRPr lang="en-US" sz="1050" dirty="0"/>
           </a:p>
@@ -10162,6 +10162,125 @@
         <p:spPr>
           <a:xfrm>
             <a:off x="457200" y="2807208"/>
+            <a:ext cx="502920" cy="292608"/>
+          </a:xfrm>
+          <a:prstGeom prst="roundRect">
+            <a:avLst>
+              <a:gd name="adj" fmla="val 25000"/>
+            </a:avLst>
+          </a:prstGeom>
+          <a:solidFill>
+            <a:schemeClr val="accent1"/>
+          </a:solidFill>
+          <a:ln w="12700">
+            <a:solidFill>
+              <a:schemeClr val="accent1"/>
+            </a:solidFill>
+            <a:prstDash val="solid"/>
+          </a:ln>
+        </p:spPr>
+      </p:sp>
+      <p:sp>
+        <p:nvSpPr>
+          <p:cNvPr id="16" name="Text 14"/>
+          <p:cNvSpPr txBox="1"/>
+          <p:nvPr/>
+        </p:nvSpPr>
+        <p:spPr>
+          <a:xfrm>
+            <a:off x="457200" y="2807208"/>
+            <a:ext cx="502920" cy="292608"/>
+          </a:xfrm>
+          <a:prstGeom prst="rect">
+            <a:avLst/>
+          </a:prstGeom>
+          <a:noFill/>
+          <a:ln/>
+        </p:spPr>
+        <p:txBody>
+          <a:bodyPr wrap="square" lIns="0" tIns="0" rIns="0" bIns="0" rtlCol="0" anchor="ctr"/>
+          <a:lstStyle/>
+          <a:p>
+            <a:pPr algn="ctr" indent="0" marL="0">
+              <a:buNone/>
+            </a:pPr>
+            <a:r>
+              <a:rPr lang="en-US" sz="1100" b="1" dirty="0">
+                <a:solidFill>
+                  <a:schemeClr val="bg1"/>
+                </a:solidFill>
+                <a:latin typeface="Calibri" pitchFamily="34" charset="0"/>
+                <a:ea typeface="Calibri" pitchFamily="34" charset="-122"/>
+                <a:cs typeface="Calibri" pitchFamily="34" charset="-120"/>
+              </a:rPr>
+              <a:t>R5</a:t>
+            </a:r>
+            <a:endParaRPr lang="en-US" sz="1100" dirty="0"/>
+          </a:p>
+        </p:txBody>
+      </p:sp>
+      <p:sp>
+        <p:nvSpPr>
+          <p:cNvPr id="17" name="Text 15"/>
+          <p:cNvSpPr txBox="1"/>
+          <p:nvPr/>
+        </p:nvSpPr>
+        <p:spPr>
+          <a:xfrm>
+            <a:off x="1051560" y="2788920"/>
+            <a:ext cx="3520440" cy="347472"/>
+          </a:xfrm>
+          <a:prstGeom prst="rect">
+            <a:avLst/>
+          </a:prstGeom>
+          <a:noFill/>
+          <a:ln/>
+        </p:spPr>
+        <p:txBody>
+          <a:bodyPr wrap="square" lIns="0" tIns="0" rIns="0" bIns="0" rtlCol="0" anchor="ctr"/>
+          <a:lstStyle/>
+          <a:p>
+            <a:pPr indent="0" marL="0">
+              <a:buNone/>
+            </a:pPr>
+            <a:r>
+              <a:rPr lang="en-US" sz="1050" b="1" dirty="0">
+                <a:solidFill>
+                  <a:schemeClr val="tx1"/>
+                </a:solidFill>
+                <a:latin typeface="Calibri" pitchFamily="34" charset="0"/>
+                <a:ea typeface="Calibri" pitchFamily="34" charset="-122"/>
+                <a:cs typeface="Calibri" pitchFamily="34" charset="-120"/>
+              </a:rPr>
+              <a:t>Retrabalho limitado</a:t>
+            </a:r>
+            <a:pPr indent="0" marL="0">
+              <a:buNone/>
+            </a:pPr>
+            <a:r>
+              <a:rPr lang="en-US" sz="1050" dirty="0">
+                <a:solidFill>
+                  <a:schemeClr val="accent5"/>
+                </a:solidFill>
+                <a:latin typeface="Calibri" pitchFamily="34" charset="0"/>
+                <a:ea typeface="Calibri" pitchFamily="34" charset="-122"/>
+                <a:cs typeface="Calibri" pitchFamily="34" charset="-120"/>
+              </a:rPr>
+              <a:t>  limite de 3 ciclos definido e testado; ainda não acionado automaticamente</a:t>
+            </a:r>
+            <a:endParaRPr lang="en-US" sz="1050" dirty="0"/>
+          </a:p>
+        </p:txBody>
+      </p:sp>
+      <p:sp>
+        <p:nvSpPr>
+          <p:cNvPr id="18" name="Shape 16"/>
+          <p:cNvSpPr/>
+          <p:nvPr/>
+        </p:nvSpPr>
+        <p:spPr>
+          <a:xfrm>
+            <a:off x="457200" y="3236976"/>
             <a:ext cx="502920" cy="292608"/>
           </a:xfrm>
           <a:prstGeom prst="roundRect">
@@ -10182,13 +10301,13 @@
       </p:sp>
       <p:sp>
         <p:nvSpPr>
-          <p:cNvPr id="16" name="Text 14"/>
-          <p:cNvSpPr txBox="1"/>
-          <p:nvPr/>
-        </p:nvSpPr>
-        <p:spPr>
-          <a:xfrm>
-            <a:off x="457200" y="2807208"/>
+          <p:cNvPr id="19" name="Text 17"/>
+          <p:cNvSpPr txBox="1"/>
+          <p:nvPr/>
+        </p:nvSpPr>
+        <p:spPr>
+          <a:xfrm>
+            <a:off x="457200" y="3236976"/>
             <a:ext cx="502920" cy="292608"/>
           </a:xfrm>
           <a:prstGeom prst="rect">
@@ -10213,7 +10332,7 @@
                 <a:ea typeface="Calibri" pitchFamily="34" charset="-122"/>
                 <a:cs typeface="Calibri" pitchFamily="34" charset="-120"/>
               </a:rPr>
-              <a:t>R5</a:t>
+              <a:t>R6</a:t>
             </a:r>
             <a:endParaRPr lang="en-US" sz="1100" dirty="0"/>
           </a:p>
@@ -10221,13 +10340,13 @@
       </p:sp>
       <p:sp>
         <p:nvSpPr>
-          <p:cNvPr id="17" name="Text 15"/>
-          <p:cNvSpPr txBox="1"/>
-          <p:nvPr/>
-        </p:nvSpPr>
-        <p:spPr>
-          <a:xfrm>
-            <a:off x="1051560" y="2788920"/>
+          <p:cNvPr id="20" name="Text 18"/>
+          <p:cNvSpPr txBox="1"/>
+          <p:nvPr/>
+        </p:nvSpPr>
+        <p:spPr>
+          <a:xfrm>
+            <a:off x="1051560" y="3218688"/>
             <a:ext cx="3520440" cy="347472"/>
           </a:xfrm>
           <a:prstGeom prst="rect">
@@ -10252,7 +10371,7 @@
                 <a:ea typeface="Calibri" pitchFamily="34" charset="-122"/>
                 <a:cs typeface="Calibri" pitchFamily="34" charset="-120"/>
               </a:rPr>
-              <a:t>Retrabalho limitado</a:t>
+              <a:t>Paralelismo sem disputa</a:t>
             </a:r>
             <a:pPr indent="0" marL="0">
               <a:buNone/>
@@ -10266,7 +10385,7 @@
                 <a:ea typeface="Calibri" pitchFamily="34" charset="-122"/>
                 <a:cs typeface="Calibri" pitchFamily="34" charset="-120"/>
               </a:rPr>
-              <a:t>  humano no 4º ciclo</a:t>
+              <a:t>  teste do marco E5</a:t>
             </a:r>
             <a:endParaRPr lang="en-US" sz="1050" dirty="0"/>
           </a:p>
@@ -10274,13 +10393,370 @@
       </p:sp>
       <p:sp>
         <p:nvSpPr>
-          <p:cNvPr id="18" name="Shape 16"/>
+          <p:cNvPr id="21" name="Shape 19"/>
           <p:cNvSpPr/>
           <p:nvPr/>
         </p:nvSpPr>
         <p:spPr>
           <a:xfrm>
-            <a:off x="457200" y="3236976"/>
+            <a:off x="457200" y="3666744"/>
+            <a:ext cx="502920" cy="292608"/>
+          </a:xfrm>
+          <a:prstGeom prst="roundRect">
+            <a:avLst>
+              <a:gd name="adj" fmla="val 25000"/>
+            </a:avLst>
+          </a:prstGeom>
+          <a:solidFill>
+            <a:schemeClr val="accent3"/>
+          </a:solidFill>
+          <a:ln w="12700">
+            <a:solidFill>
+              <a:schemeClr val="accent3"/>
+            </a:solidFill>
+            <a:prstDash val="solid"/>
+          </a:ln>
+        </p:spPr>
+      </p:sp>
+      <p:sp>
+        <p:nvSpPr>
+          <p:cNvPr id="22" name="Text 20"/>
+          <p:cNvSpPr txBox="1"/>
+          <p:nvPr/>
+        </p:nvSpPr>
+        <p:spPr>
+          <a:xfrm>
+            <a:off x="457200" y="3666744"/>
+            <a:ext cx="502920" cy="292608"/>
+          </a:xfrm>
+          <a:prstGeom prst="rect">
+            <a:avLst/>
+          </a:prstGeom>
+          <a:noFill/>
+          <a:ln/>
+        </p:spPr>
+        <p:txBody>
+          <a:bodyPr wrap="square" lIns="0" tIns="0" rIns="0" bIns="0" rtlCol="0" anchor="ctr"/>
+          <a:lstStyle/>
+          <a:p>
+            <a:pPr algn="ctr" indent="0" marL="0">
+              <a:buNone/>
+            </a:pPr>
+            <a:r>
+              <a:rPr lang="en-US" sz="1100" b="1" dirty="0">
+                <a:solidFill>
+                  <a:schemeClr val="bg1"/>
+                </a:solidFill>
+                <a:latin typeface="Calibri" pitchFamily="34" charset="0"/>
+                <a:ea typeface="Calibri" pitchFamily="34" charset="-122"/>
+                <a:cs typeface="Calibri" pitchFamily="34" charset="-120"/>
+              </a:rPr>
+              <a:t>R7</a:t>
+            </a:r>
+            <a:endParaRPr lang="en-US" sz="1100" dirty="0"/>
+          </a:p>
+        </p:txBody>
+      </p:sp>
+      <p:sp>
+        <p:nvSpPr>
+          <p:cNvPr id="23" name="Text 21"/>
+          <p:cNvSpPr txBox="1"/>
+          <p:nvPr/>
+        </p:nvSpPr>
+        <p:spPr>
+          <a:xfrm>
+            <a:off x="1051560" y="3648456"/>
+            <a:ext cx="3520440" cy="347472"/>
+          </a:xfrm>
+          <a:prstGeom prst="rect">
+            <a:avLst/>
+          </a:prstGeom>
+          <a:noFill/>
+          <a:ln/>
+        </p:spPr>
+        <p:txBody>
+          <a:bodyPr wrap="square" lIns="0" tIns="0" rIns="0" bIns="0" rtlCol="0" anchor="ctr"/>
+          <a:lstStyle/>
+          <a:p>
+            <a:pPr indent="0" marL="0">
+              <a:buNone/>
+            </a:pPr>
+            <a:r>
+              <a:rPr lang="en-US" sz="1050" b="1" dirty="0">
+                <a:solidFill>
+                  <a:schemeClr val="tx1"/>
+                </a:solidFill>
+                <a:latin typeface="Calibri" pitchFamily="34" charset="0"/>
+                <a:ea typeface="Calibri" pitchFamily="34" charset="-122"/>
+                <a:cs typeface="Calibri" pitchFamily="34" charset="-120"/>
+              </a:rPr>
+              <a:t>Histórico citado com fonte</a:t>
+            </a:r>
+            <a:pPr indent="0" marL="0">
+              <a:buNone/>
+            </a:pPr>
+            <a:r>
+              <a:rPr lang="en-US" sz="1050" dirty="0">
+                <a:solidFill>
+                  <a:schemeClr val="accent5"/>
+                </a:solidFill>
+                <a:latin typeface="Calibri" pitchFamily="34" charset="0"/>
+                <a:ea typeface="Calibri" pitchFamily="34" charset="-122"/>
+                <a:cs typeface="Calibri" pitchFamily="34" charset="-120"/>
+              </a:rPr>
+              <a:t>  bloco ainda não chega ao agente</a:t>
+            </a:r>
+            <a:endParaRPr lang="en-US" sz="1050" dirty="0"/>
+          </a:p>
+        </p:txBody>
+      </p:sp>
+      <p:sp>
+        <p:nvSpPr>
+          <p:cNvPr id="24" name="Shape 22"/>
+          <p:cNvSpPr/>
+          <p:nvPr/>
+        </p:nvSpPr>
+        <p:spPr>
+          <a:xfrm>
+            <a:off x="457200" y="4096512"/>
+            <a:ext cx="502920" cy="292608"/>
+          </a:xfrm>
+          <a:prstGeom prst="roundRect">
+            <a:avLst>
+              <a:gd name="adj" fmla="val 25000"/>
+            </a:avLst>
+          </a:prstGeom>
+          <a:solidFill>
+            <a:schemeClr val="accent1"/>
+          </a:solidFill>
+          <a:ln w="12700">
+            <a:solidFill>
+              <a:schemeClr val="accent1"/>
+            </a:solidFill>
+            <a:prstDash val="solid"/>
+          </a:ln>
+        </p:spPr>
+      </p:sp>
+      <p:sp>
+        <p:nvSpPr>
+          <p:cNvPr id="25" name="Text 23"/>
+          <p:cNvSpPr txBox="1"/>
+          <p:nvPr/>
+        </p:nvSpPr>
+        <p:spPr>
+          <a:xfrm>
+            <a:off x="457200" y="4096512"/>
+            <a:ext cx="502920" cy="292608"/>
+          </a:xfrm>
+          <a:prstGeom prst="rect">
+            <a:avLst/>
+          </a:prstGeom>
+          <a:noFill/>
+          <a:ln/>
+        </p:spPr>
+        <p:txBody>
+          <a:bodyPr wrap="square" lIns="0" tIns="0" rIns="0" bIns="0" rtlCol="0" anchor="ctr"/>
+          <a:lstStyle/>
+          <a:p>
+            <a:pPr algn="ctr" indent="0" marL="0">
+              <a:buNone/>
+            </a:pPr>
+            <a:r>
+              <a:rPr lang="en-US" sz="1100" b="1" dirty="0">
+                <a:solidFill>
+                  <a:schemeClr val="bg1"/>
+                </a:solidFill>
+                <a:latin typeface="Calibri" pitchFamily="34" charset="0"/>
+                <a:ea typeface="Calibri" pitchFamily="34" charset="-122"/>
+                <a:cs typeface="Calibri" pitchFamily="34" charset="-120"/>
+              </a:rPr>
+              <a:t>R8</a:t>
+            </a:r>
+            <a:endParaRPr lang="en-US" sz="1100" dirty="0"/>
+          </a:p>
+        </p:txBody>
+      </p:sp>
+      <p:sp>
+        <p:nvSpPr>
+          <p:cNvPr id="26" name="Text 24"/>
+          <p:cNvSpPr txBox="1"/>
+          <p:nvPr/>
+        </p:nvSpPr>
+        <p:spPr>
+          <a:xfrm>
+            <a:off x="1051560" y="4078224"/>
+            <a:ext cx="3520440" cy="347472"/>
+          </a:xfrm>
+          <a:prstGeom prst="rect">
+            <a:avLst/>
+          </a:prstGeom>
+          <a:noFill/>
+          <a:ln/>
+        </p:spPr>
+        <p:txBody>
+          <a:bodyPr wrap="square" lIns="0" tIns="0" rIns="0" bIns="0" rtlCol="0" anchor="ctr"/>
+          <a:lstStyle/>
+          <a:p>
+            <a:pPr indent="0" marL="0">
+              <a:buNone/>
+            </a:pPr>
+            <a:r>
+              <a:rPr lang="en-US" sz="1050" b="1" dirty="0">
+                <a:solidFill>
+                  <a:schemeClr val="tx1"/>
+                </a:solidFill>
+                <a:latin typeface="Calibri" pitchFamily="34" charset="0"/>
+                <a:ea typeface="Calibri" pitchFamily="34" charset="-122"/>
+                <a:cs typeface="Calibri" pitchFamily="34" charset="-120"/>
+              </a:rPr>
+              <a:t>Andamento e custo ao vivo</a:t>
+            </a:r>
+            <a:pPr indent="0" marL="0">
+              <a:buNone/>
+            </a:pPr>
+            <a:r>
+              <a:rPr lang="en-US" sz="1050" dirty="0">
+                <a:solidFill>
+                  <a:schemeClr val="accent5"/>
+                </a:solidFill>
+                <a:latin typeface="Calibri" pitchFamily="34" charset="0"/>
+                <a:ea typeface="Calibri" pitchFamily="34" charset="-122"/>
+                <a:cs typeface="Calibri" pitchFamily="34" charset="-120"/>
+              </a:rPr>
+              <a:t>  tela pronta; projeto inteiro pendente</a:t>
+            </a:r>
+            <a:endParaRPr lang="en-US" sz="1050" dirty="0"/>
+          </a:p>
+        </p:txBody>
+      </p:sp>
+      <p:sp>
+        <p:nvSpPr>
+          <p:cNvPr id="27" name="Shape 25"/>
+          <p:cNvSpPr/>
+          <p:nvPr/>
+        </p:nvSpPr>
+        <p:spPr>
+          <a:xfrm>
+            <a:off x="4663440" y="1088136"/>
+            <a:ext cx="502920" cy="292608"/>
+          </a:xfrm>
+          <a:prstGeom prst="roundRect">
+            <a:avLst>
+              <a:gd name="adj" fmla="val 25000"/>
+            </a:avLst>
+          </a:prstGeom>
+          <a:solidFill>
+            <a:schemeClr val="accent1"/>
+          </a:solidFill>
+          <a:ln w="12700">
+            <a:solidFill>
+              <a:schemeClr val="accent1"/>
+            </a:solidFill>
+            <a:prstDash val="solid"/>
+          </a:ln>
+        </p:spPr>
+      </p:sp>
+      <p:sp>
+        <p:nvSpPr>
+          <p:cNvPr id="28" name="Text 26"/>
+          <p:cNvSpPr txBox="1"/>
+          <p:nvPr/>
+        </p:nvSpPr>
+        <p:spPr>
+          <a:xfrm>
+            <a:off x="4663440" y="1088136"/>
+            <a:ext cx="502920" cy="292608"/>
+          </a:xfrm>
+          <a:prstGeom prst="rect">
+            <a:avLst/>
+          </a:prstGeom>
+          <a:noFill/>
+          <a:ln/>
+        </p:spPr>
+        <p:txBody>
+          <a:bodyPr wrap="square" lIns="0" tIns="0" rIns="0" bIns="0" rtlCol="0" anchor="ctr"/>
+          <a:lstStyle/>
+          <a:p>
+            <a:pPr algn="ctr" indent="0" marL="0">
+              <a:buNone/>
+            </a:pPr>
+            <a:r>
+              <a:rPr lang="en-US" sz="1100" b="1" dirty="0">
+                <a:solidFill>
+                  <a:schemeClr val="bg1"/>
+                </a:solidFill>
+                <a:latin typeface="Calibri" pitchFamily="34" charset="0"/>
+                <a:ea typeface="Calibri" pitchFamily="34" charset="-122"/>
+                <a:cs typeface="Calibri" pitchFamily="34" charset="-120"/>
+              </a:rPr>
+              <a:t>R9</a:t>
+            </a:r>
+            <a:endParaRPr lang="en-US" sz="1100" dirty="0"/>
+          </a:p>
+        </p:txBody>
+      </p:sp>
+      <p:sp>
+        <p:nvSpPr>
+          <p:cNvPr id="29" name="Text 27"/>
+          <p:cNvSpPr txBox="1"/>
+          <p:nvPr/>
+        </p:nvSpPr>
+        <p:spPr>
+          <a:xfrm>
+            <a:off x="5257800" y="1069848"/>
+            <a:ext cx="3520440" cy="347472"/>
+          </a:xfrm>
+          <a:prstGeom prst="rect">
+            <a:avLst/>
+          </a:prstGeom>
+          <a:noFill/>
+          <a:ln/>
+        </p:spPr>
+        <p:txBody>
+          <a:bodyPr wrap="square" lIns="0" tIns="0" rIns="0" bIns="0" rtlCol="0" anchor="ctr"/>
+          <a:lstStyle/>
+          <a:p>
+            <a:pPr indent="0" marL="0">
+              <a:buNone/>
+            </a:pPr>
+            <a:r>
+              <a:rPr lang="en-US" sz="1050" b="1" dirty="0">
+                <a:solidFill>
+                  <a:schemeClr val="tx1"/>
+                </a:solidFill>
+                <a:latin typeface="Calibri" pitchFamily="34" charset="0"/>
+                <a:ea typeface="Calibri" pitchFamily="34" charset="-122"/>
+                <a:cs typeface="Calibri" pitchFamily="34" charset="-120"/>
+              </a:rPr>
+              <a:t>Cabe em 8 GB / 4 núcleos</a:t>
+            </a:r>
+            <a:pPr indent="0" marL="0">
+              <a:buNone/>
+            </a:pPr>
+            <a:r>
+              <a:rPr lang="en-US" sz="1050" dirty="0">
+                <a:solidFill>
+                  <a:schemeClr val="accent5"/>
+                </a:solidFill>
+                <a:latin typeface="Calibri" pitchFamily="34" charset="0"/>
+                <a:ea typeface="Calibri" pitchFamily="34" charset="-122"/>
+                <a:cs typeface="Calibri" pitchFamily="34" charset="-120"/>
+              </a:rPr>
+              <a:t>  busca medida; pico com 3 em paralelo a medir</a:t>
+            </a:r>
+            <a:endParaRPr lang="en-US" sz="1050" dirty="0"/>
+          </a:p>
+        </p:txBody>
+      </p:sp>
+      <p:sp>
+        <p:nvSpPr>
+          <p:cNvPr id="30" name="Shape 28"/>
+          <p:cNvSpPr/>
+          <p:nvPr/>
+        </p:nvSpPr>
+        <p:spPr>
+          <a:xfrm>
+            <a:off x="4663440" y="1517904"/>
             <a:ext cx="502920" cy="292608"/>
           </a:xfrm>
           <a:prstGeom prst="roundRect">
@@ -10301,13 +10777,13 @@
       </p:sp>
       <p:sp>
         <p:nvSpPr>
-          <p:cNvPr id="19" name="Text 17"/>
-          <p:cNvSpPr txBox="1"/>
-          <p:nvPr/>
-        </p:nvSpPr>
-        <p:spPr>
-          <a:xfrm>
-            <a:off x="457200" y="3236976"/>
+          <p:cNvPr id="31" name="Text 29"/>
+          <p:cNvSpPr txBox="1"/>
+          <p:nvPr/>
+        </p:nvSpPr>
+        <p:spPr>
+          <a:xfrm>
+            <a:off x="4663440" y="1517904"/>
             <a:ext cx="502920" cy="292608"/>
           </a:xfrm>
           <a:prstGeom prst="rect">
@@ -10332,7 +10808,7 @@
                 <a:ea typeface="Calibri" pitchFamily="34" charset="-122"/>
                 <a:cs typeface="Calibri" pitchFamily="34" charset="-120"/>
               </a:rPr>
-              <a:t>R6</a:t>
+              <a:t>R10</a:t>
             </a:r>
             <a:endParaRPr lang="en-US" sz="1100" dirty="0"/>
           </a:p>
@@ -10340,13 +10816,13 @@
       </p:sp>
       <p:sp>
         <p:nvSpPr>
-          <p:cNvPr id="20" name="Text 18"/>
-          <p:cNvSpPr txBox="1"/>
-          <p:nvPr/>
-        </p:nvSpPr>
-        <p:spPr>
-          <a:xfrm>
-            <a:off x="1051560" y="3218688"/>
+          <p:cNvPr id="32" name="Text 30"/>
+          <p:cNvSpPr txBox="1"/>
+          <p:nvPr/>
+        </p:nvSpPr>
+        <p:spPr>
+          <a:xfrm>
+            <a:off x="5257800" y="1499616"/>
             <a:ext cx="3520440" cy="347472"/>
           </a:xfrm>
           <a:prstGeom prst="rect">
@@ -10371,7 +10847,7 @@
                 <a:ea typeface="Calibri" pitchFamily="34" charset="-122"/>
                 <a:cs typeface="Calibri" pitchFamily="34" charset="-120"/>
               </a:rPr>
-              <a:t>Paralelismo sem disputa</a:t>
+              <a:t>Custo em cota e dinheiro</a:t>
             </a:r>
             <a:pPr indent="0" marL="0">
               <a:buNone/>
@@ -10385,7 +10861,7 @@
                 <a:ea typeface="Calibri" pitchFamily="34" charset="-122"/>
                 <a:cs typeface="Calibri" pitchFamily="34" charset="-120"/>
               </a:rPr>
-              <a:t>  teste do marco E5</a:t>
+              <a:t>  consumos em cota e US$</a:t>
             </a:r>
             <a:endParaRPr lang="en-US" sz="1050" dirty="0"/>
           </a:p>
@@ -10393,13 +10869,13 @@
       </p:sp>
       <p:sp>
         <p:nvSpPr>
-          <p:cNvPr id="21" name="Shape 19"/>
+          <p:cNvPr id="33" name="Shape 31"/>
           <p:cNvSpPr/>
           <p:nvPr/>
         </p:nvSpPr>
         <p:spPr>
           <a:xfrm>
-            <a:off x="457200" y="3666744"/>
+            <a:off x="4663440" y="1947672"/>
             <a:ext cx="502920" cy="292608"/>
           </a:xfrm>
           <a:prstGeom prst="roundRect">
@@ -10408,11 +10884,11 @@
             </a:avLst>
           </a:prstGeom>
           <a:solidFill>
-            <a:schemeClr val="accent3"/>
+            <a:schemeClr val="accent2"/>
           </a:solidFill>
           <a:ln w="12700">
             <a:solidFill>
-              <a:schemeClr val="accent3"/>
+              <a:schemeClr val="accent2"/>
             </a:solidFill>
             <a:prstDash val="solid"/>
           </a:ln>
@@ -10420,13 +10896,13 @@
       </p:sp>
       <p:sp>
         <p:nvSpPr>
-          <p:cNvPr id="22" name="Text 20"/>
-          <p:cNvSpPr txBox="1"/>
-          <p:nvPr/>
-        </p:nvSpPr>
-        <p:spPr>
-          <a:xfrm>
-            <a:off x="457200" y="3666744"/>
+          <p:cNvPr id="34" name="Text 32"/>
+          <p:cNvSpPr txBox="1"/>
+          <p:nvPr/>
+        </p:nvSpPr>
+        <p:spPr>
+          <a:xfrm>
+            <a:off x="4663440" y="1947672"/>
             <a:ext cx="502920" cy="292608"/>
           </a:xfrm>
           <a:prstGeom prst="rect">
@@ -10451,7 +10927,7 @@
                 <a:ea typeface="Calibri" pitchFamily="34" charset="-122"/>
                 <a:cs typeface="Calibri" pitchFamily="34" charset="-120"/>
               </a:rPr>
-              <a:t>R7</a:t>
+              <a:t>R11</a:t>
             </a:r>
             <a:endParaRPr lang="en-US" sz="1100" dirty="0"/>
           </a:p>
@@ -10459,13 +10935,13 @@
       </p:sp>
       <p:sp>
         <p:nvSpPr>
-          <p:cNvPr id="23" name="Text 21"/>
-          <p:cNvSpPr txBox="1"/>
-          <p:nvPr/>
-        </p:nvSpPr>
-        <p:spPr>
-          <a:xfrm>
-            <a:off x="1051560" y="3648456"/>
+          <p:cNvPr id="35" name="Text 33"/>
+          <p:cNvSpPr txBox="1"/>
+          <p:nvPr/>
+        </p:nvSpPr>
+        <p:spPr>
+          <a:xfrm>
+            <a:off x="5257800" y="1929384"/>
             <a:ext cx="3520440" cy="347472"/>
           </a:xfrm>
           <a:prstGeom prst="rect">
@@ -10490,7 +10966,7 @@
                 <a:ea typeface="Calibri" pitchFamily="34" charset="-122"/>
                 <a:cs typeface="Calibri" pitchFamily="34" charset="-120"/>
               </a:rPr>
-              <a:t>Histórico citado com fonte</a:t>
+              <a:t>Nada escrito fora do projeto</a:t>
             </a:r>
             <a:pPr indent="0" marL="0">
               <a:buNone/>
@@ -10504,7 +10980,7 @@
                 <a:ea typeface="Calibri" pitchFamily="34" charset="-122"/>
                 <a:cs typeface="Calibri" pitchFamily="34" charset="-120"/>
               </a:rPr>
-              <a:t>  bloco ainda não chega ao agente</a:t>
+              <a:t>  confinamento + sandbox</a:t>
             </a:r>
             <a:endParaRPr lang="en-US" sz="1050" dirty="0"/>
           </a:p>
@@ -10512,13 +10988,251 @@
       </p:sp>
       <p:sp>
         <p:nvSpPr>
-          <p:cNvPr id="24" name="Shape 22"/>
+          <p:cNvPr id="36" name="Shape 34"/>
           <p:cNvSpPr/>
           <p:nvPr/>
         </p:nvSpPr>
         <p:spPr>
           <a:xfrm>
-            <a:off x="457200" y="4096512"/>
+            <a:off x="4663440" y="2377440"/>
+            <a:ext cx="502920" cy="292608"/>
+          </a:xfrm>
+          <a:prstGeom prst="roundRect">
+            <a:avLst>
+              <a:gd name="adj" fmla="val 25000"/>
+            </a:avLst>
+          </a:prstGeom>
+          <a:solidFill>
+            <a:schemeClr val="accent2"/>
+          </a:solidFill>
+          <a:ln w="12700">
+            <a:solidFill>
+              <a:schemeClr val="accent2"/>
+            </a:solidFill>
+            <a:prstDash val="solid"/>
+          </a:ln>
+        </p:spPr>
+      </p:sp>
+      <p:sp>
+        <p:nvSpPr>
+          <p:cNvPr id="37" name="Text 35"/>
+          <p:cNvSpPr txBox="1"/>
+          <p:nvPr/>
+        </p:nvSpPr>
+        <p:spPr>
+          <a:xfrm>
+            <a:off x="4663440" y="2377440"/>
+            <a:ext cx="502920" cy="292608"/>
+          </a:xfrm>
+          <a:prstGeom prst="rect">
+            <a:avLst/>
+          </a:prstGeom>
+          <a:noFill/>
+          <a:ln/>
+        </p:spPr>
+        <p:txBody>
+          <a:bodyPr wrap="square" lIns="0" tIns="0" rIns="0" bIns="0" rtlCol="0" anchor="ctr"/>
+          <a:lstStyle/>
+          <a:p>
+            <a:pPr algn="ctr" indent="0" marL="0">
+              <a:buNone/>
+            </a:pPr>
+            <a:r>
+              <a:rPr lang="en-US" sz="1100" b="1" dirty="0">
+                <a:solidFill>
+                  <a:schemeClr val="bg1"/>
+                </a:solidFill>
+                <a:latin typeface="Calibri" pitchFamily="34" charset="0"/>
+                <a:ea typeface="Calibri" pitchFamily="34" charset="-122"/>
+                <a:cs typeface="Calibri" pitchFamily="34" charset="-120"/>
+              </a:rPr>
+              <a:t>R12</a:t>
+            </a:r>
+            <a:endParaRPr lang="en-US" sz="1100" dirty="0"/>
+          </a:p>
+        </p:txBody>
+      </p:sp>
+      <p:sp>
+        <p:nvSpPr>
+          <p:cNvPr id="38" name="Text 36"/>
+          <p:cNvSpPr txBox="1"/>
+          <p:nvPr/>
+        </p:nvSpPr>
+        <p:spPr>
+          <a:xfrm>
+            <a:off x="5257800" y="2359152"/>
+            <a:ext cx="3520440" cy="347472"/>
+          </a:xfrm>
+          <a:prstGeom prst="rect">
+            <a:avLst/>
+          </a:prstGeom>
+          <a:noFill/>
+          <a:ln/>
+        </p:spPr>
+        <p:txBody>
+          <a:bodyPr wrap="square" lIns="0" tIns="0" rIns="0" bIns="0" rtlCol="0" anchor="ctr"/>
+          <a:lstStyle/>
+          <a:p>
+            <a:pPr indent="0" marL="0">
+              <a:buNone/>
+            </a:pPr>
+            <a:r>
+              <a:rPr lang="en-US" sz="1050" b="1" dirty="0">
+                <a:solidFill>
+                  <a:schemeClr val="tx1"/>
+                </a:solidFill>
+                <a:latin typeface="Calibri" pitchFamily="34" charset="0"/>
+                <a:ea typeface="Calibri" pitchFamily="34" charset="-122"/>
+                <a:cs typeface="Calibri" pitchFamily="34" charset="-120"/>
+              </a:rPr>
+              <a:t>Testes sem internet e sem cota</a:t>
+            </a:r>
+            <a:pPr indent="0" marL="0">
+              <a:buNone/>
+            </a:pPr>
+            <a:r>
+              <a:rPr lang="en-US" sz="1050" dirty="0">
+                <a:solidFill>
+                  <a:schemeClr val="accent5"/>
+                </a:solidFill>
+                <a:latin typeface="Calibri" pitchFamily="34" charset="0"/>
+                <a:ea typeface="Calibri" pitchFamily="34" charset="-122"/>
+                <a:cs typeface="Calibri" pitchFamily="34" charset="-120"/>
+              </a:rPr>
+              <a:t>  teste do marco E2</a:t>
+            </a:r>
+            <a:endParaRPr lang="en-US" sz="1050" dirty="0"/>
+          </a:p>
+        </p:txBody>
+      </p:sp>
+      <p:sp>
+        <p:nvSpPr>
+          <p:cNvPr id="39" name="Shape 37"/>
+          <p:cNvSpPr/>
+          <p:nvPr/>
+        </p:nvSpPr>
+        <p:spPr>
+          <a:xfrm>
+            <a:off x="4663440" y="2807208"/>
+            <a:ext cx="502920" cy="292608"/>
+          </a:xfrm>
+          <a:prstGeom prst="roundRect">
+            <a:avLst>
+              <a:gd name="adj" fmla="val 25000"/>
+            </a:avLst>
+          </a:prstGeom>
+          <a:solidFill>
+            <a:schemeClr val="accent2"/>
+          </a:solidFill>
+          <a:ln w="12700">
+            <a:solidFill>
+              <a:schemeClr val="accent2"/>
+            </a:solidFill>
+            <a:prstDash val="solid"/>
+          </a:ln>
+        </p:spPr>
+      </p:sp>
+      <p:sp>
+        <p:nvSpPr>
+          <p:cNvPr id="40" name="Text 38"/>
+          <p:cNvSpPr txBox="1"/>
+          <p:nvPr/>
+        </p:nvSpPr>
+        <p:spPr>
+          <a:xfrm>
+            <a:off x="4663440" y="2807208"/>
+            <a:ext cx="502920" cy="292608"/>
+          </a:xfrm>
+          <a:prstGeom prst="rect">
+            <a:avLst/>
+          </a:prstGeom>
+          <a:noFill/>
+          <a:ln/>
+        </p:spPr>
+        <p:txBody>
+          <a:bodyPr wrap="square" lIns="0" tIns="0" rIns="0" bIns="0" rtlCol="0" anchor="ctr"/>
+          <a:lstStyle/>
+          <a:p>
+            <a:pPr algn="ctr" indent="0" marL="0">
+              <a:buNone/>
+            </a:pPr>
+            <a:r>
+              <a:rPr lang="en-US" sz="1100" b="1" dirty="0">
+                <a:solidFill>
+                  <a:schemeClr val="bg1"/>
+                </a:solidFill>
+                <a:latin typeface="Calibri" pitchFamily="34" charset="0"/>
+                <a:ea typeface="Calibri" pitchFamily="34" charset="-122"/>
+                <a:cs typeface="Calibri" pitchFamily="34" charset="-120"/>
+              </a:rPr>
+              <a:t>R13</a:t>
+            </a:r>
+            <a:endParaRPr lang="en-US" sz="1100" dirty="0"/>
+          </a:p>
+        </p:txBody>
+      </p:sp>
+      <p:sp>
+        <p:nvSpPr>
+          <p:cNvPr id="41" name="Text 39"/>
+          <p:cNvSpPr txBox="1"/>
+          <p:nvPr/>
+        </p:nvSpPr>
+        <p:spPr>
+          <a:xfrm>
+            <a:off x="5257800" y="2788920"/>
+            <a:ext cx="3520440" cy="347472"/>
+          </a:xfrm>
+          <a:prstGeom prst="rect">
+            <a:avLst/>
+          </a:prstGeom>
+          <a:noFill/>
+          <a:ln/>
+        </p:spPr>
+        <p:txBody>
+          <a:bodyPr wrap="square" lIns="0" tIns="0" rIns="0" bIns="0" rtlCol="0" anchor="ctr"/>
+          <a:lstStyle/>
+          <a:p>
+            <a:pPr indent="0" marL="0">
+              <a:buNone/>
+            </a:pPr>
+            <a:r>
+              <a:rPr lang="en-US" sz="1050" b="1" dirty="0">
+                <a:solidFill>
+                  <a:schemeClr val="tx1"/>
+                </a:solidFill>
+                <a:latin typeface="Calibri" pitchFamily="34" charset="0"/>
+                <a:ea typeface="Calibri" pitchFamily="34" charset="-122"/>
+                <a:cs typeface="Calibri" pitchFamily="34" charset="-120"/>
+              </a:rPr>
+              <a:t>Queda isolada, sem perda</a:t>
+            </a:r>
+            <a:pPr indent="0" marL="0">
+              <a:buNone/>
+            </a:pPr>
+            <a:r>
+              <a:rPr lang="en-US" sz="1050" dirty="0">
+                <a:solidFill>
+                  <a:schemeClr val="accent5"/>
+                </a:solidFill>
+                <a:latin typeface="Calibri" pitchFamily="34" charset="0"/>
+                <a:ea typeface="Calibri" pitchFamily="34" charset="-122"/>
+                <a:cs typeface="Calibri" pitchFamily="34" charset="-120"/>
+              </a:rPr>
+              <a:t>  teste do marco E5</a:t>
+            </a:r>
+            <a:endParaRPr lang="en-US" sz="1050" dirty="0"/>
+          </a:p>
+        </p:txBody>
+      </p:sp>
+      <p:sp>
+        <p:nvSpPr>
+          <p:cNvPr id="42" name="Shape 40"/>
+          <p:cNvSpPr/>
+          <p:nvPr/>
+        </p:nvSpPr>
+        <p:spPr>
+          <a:xfrm>
+            <a:off x="4663440" y="3236976"/>
             <a:ext cx="502920" cy="292608"/>
           </a:xfrm>
           <a:prstGeom prst="roundRect">
@@ -10539,695 +11253,8 @@
       </p:sp>
       <p:sp>
         <p:nvSpPr>
-          <p:cNvPr id="25" name="Text 23"/>
-          <p:cNvSpPr txBox="1"/>
-          <p:nvPr/>
-        </p:nvSpPr>
-        <p:spPr>
-          <a:xfrm>
-            <a:off x="457200" y="4096512"/>
-            <a:ext cx="502920" cy="292608"/>
-          </a:xfrm>
-          <a:prstGeom prst="rect">
-            <a:avLst/>
-          </a:prstGeom>
-          <a:noFill/>
-          <a:ln/>
-        </p:spPr>
-        <p:txBody>
-          <a:bodyPr wrap="square" lIns="0" tIns="0" rIns="0" bIns="0" rtlCol="0" anchor="ctr"/>
-          <a:lstStyle/>
-          <a:p>
-            <a:pPr algn="ctr" indent="0" marL="0">
-              <a:buNone/>
-            </a:pPr>
-            <a:r>
-              <a:rPr lang="en-US" sz="1100" b="1" dirty="0">
-                <a:solidFill>
-                  <a:schemeClr val="bg1"/>
-                </a:solidFill>
-                <a:latin typeface="Calibri" pitchFamily="34" charset="0"/>
-                <a:ea typeface="Calibri" pitchFamily="34" charset="-122"/>
-                <a:cs typeface="Calibri" pitchFamily="34" charset="-120"/>
-              </a:rPr>
-              <a:t>R8</a:t>
-            </a:r>
-            <a:endParaRPr lang="en-US" sz="1100" dirty="0"/>
-          </a:p>
-        </p:txBody>
-      </p:sp>
-      <p:sp>
-        <p:nvSpPr>
-          <p:cNvPr id="26" name="Text 24"/>
-          <p:cNvSpPr txBox="1"/>
-          <p:nvPr/>
-        </p:nvSpPr>
-        <p:spPr>
-          <a:xfrm>
-            <a:off x="1051560" y="4078224"/>
-            <a:ext cx="3520440" cy="347472"/>
-          </a:xfrm>
-          <a:prstGeom prst="rect">
-            <a:avLst/>
-          </a:prstGeom>
-          <a:noFill/>
-          <a:ln/>
-        </p:spPr>
-        <p:txBody>
-          <a:bodyPr wrap="square" lIns="0" tIns="0" rIns="0" bIns="0" rtlCol="0" anchor="ctr"/>
-          <a:lstStyle/>
-          <a:p>
-            <a:pPr indent="0" marL="0">
-              <a:buNone/>
-            </a:pPr>
-            <a:r>
-              <a:rPr lang="en-US" sz="1050" b="1" dirty="0">
-                <a:solidFill>
-                  <a:schemeClr val="tx1"/>
-                </a:solidFill>
-                <a:latin typeface="Calibri" pitchFamily="34" charset="0"/>
-                <a:ea typeface="Calibri" pitchFamily="34" charset="-122"/>
-                <a:cs typeface="Calibri" pitchFamily="34" charset="-120"/>
-              </a:rPr>
-              <a:t>Andamento e custo ao vivo</a:t>
-            </a:r>
-            <a:pPr indent="0" marL="0">
-              <a:buNone/>
-            </a:pPr>
-            <a:r>
-              <a:rPr lang="en-US" sz="1050" dirty="0">
-                <a:solidFill>
-                  <a:schemeClr val="accent5"/>
-                </a:solidFill>
-                <a:latin typeface="Calibri" pitchFamily="34" charset="0"/>
-                <a:ea typeface="Calibri" pitchFamily="34" charset="-122"/>
-                <a:cs typeface="Calibri" pitchFamily="34" charset="-120"/>
-              </a:rPr>
-              <a:t>  tela pronta; projeto inteiro pendente</a:t>
-            </a:r>
-            <a:endParaRPr lang="en-US" sz="1050" dirty="0"/>
-          </a:p>
-        </p:txBody>
-      </p:sp>
-      <p:sp>
-        <p:nvSpPr>
-          <p:cNvPr id="27" name="Shape 25"/>
-          <p:cNvSpPr/>
-          <p:nvPr/>
-        </p:nvSpPr>
-        <p:spPr>
-          <a:xfrm>
-            <a:off x="4663440" y="1088136"/>
-            <a:ext cx="502920" cy="292608"/>
-          </a:xfrm>
-          <a:prstGeom prst="roundRect">
-            <a:avLst>
-              <a:gd name="adj" fmla="val 25000"/>
-            </a:avLst>
-          </a:prstGeom>
-          <a:solidFill>
-            <a:schemeClr val="accent1"/>
-          </a:solidFill>
-          <a:ln w="12700">
-            <a:solidFill>
-              <a:schemeClr val="accent1"/>
-            </a:solidFill>
-            <a:prstDash val="solid"/>
-          </a:ln>
-        </p:spPr>
-      </p:sp>
-      <p:sp>
-        <p:nvSpPr>
-          <p:cNvPr id="28" name="Text 26"/>
-          <p:cNvSpPr txBox="1"/>
-          <p:nvPr/>
-        </p:nvSpPr>
-        <p:spPr>
-          <a:xfrm>
-            <a:off x="4663440" y="1088136"/>
-            <a:ext cx="502920" cy="292608"/>
-          </a:xfrm>
-          <a:prstGeom prst="rect">
-            <a:avLst/>
-          </a:prstGeom>
-          <a:noFill/>
-          <a:ln/>
-        </p:spPr>
-        <p:txBody>
-          <a:bodyPr wrap="square" lIns="0" tIns="0" rIns="0" bIns="0" rtlCol="0" anchor="ctr"/>
-          <a:lstStyle/>
-          <a:p>
-            <a:pPr algn="ctr" indent="0" marL="0">
-              <a:buNone/>
-            </a:pPr>
-            <a:r>
-              <a:rPr lang="en-US" sz="1100" b="1" dirty="0">
-                <a:solidFill>
-                  <a:schemeClr val="bg1"/>
-                </a:solidFill>
-                <a:latin typeface="Calibri" pitchFamily="34" charset="0"/>
-                <a:ea typeface="Calibri" pitchFamily="34" charset="-122"/>
-                <a:cs typeface="Calibri" pitchFamily="34" charset="-120"/>
-              </a:rPr>
-              <a:t>R9</a:t>
-            </a:r>
-            <a:endParaRPr lang="en-US" sz="1100" dirty="0"/>
-          </a:p>
-        </p:txBody>
-      </p:sp>
-      <p:sp>
-        <p:nvSpPr>
-          <p:cNvPr id="29" name="Text 27"/>
-          <p:cNvSpPr txBox="1"/>
-          <p:nvPr/>
-        </p:nvSpPr>
-        <p:spPr>
-          <a:xfrm>
-            <a:off x="5257800" y="1069848"/>
-            <a:ext cx="3520440" cy="347472"/>
-          </a:xfrm>
-          <a:prstGeom prst="rect">
-            <a:avLst/>
-          </a:prstGeom>
-          <a:noFill/>
-          <a:ln/>
-        </p:spPr>
-        <p:txBody>
-          <a:bodyPr wrap="square" lIns="0" tIns="0" rIns="0" bIns="0" rtlCol="0" anchor="ctr"/>
-          <a:lstStyle/>
-          <a:p>
-            <a:pPr indent="0" marL="0">
-              <a:buNone/>
-            </a:pPr>
-            <a:r>
-              <a:rPr lang="en-US" sz="1050" b="1" dirty="0">
-                <a:solidFill>
-                  <a:schemeClr val="tx1"/>
-                </a:solidFill>
-                <a:latin typeface="Calibri" pitchFamily="34" charset="0"/>
-                <a:ea typeface="Calibri" pitchFamily="34" charset="-122"/>
-                <a:cs typeface="Calibri" pitchFamily="34" charset="-120"/>
-              </a:rPr>
-              <a:t>Cabe em 8 GB / 4 núcleos</a:t>
-            </a:r>
-            <a:pPr indent="0" marL="0">
-              <a:buNone/>
-            </a:pPr>
-            <a:r>
-              <a:rPr lang="en-US" sz="1050" dirty="0">
-                <a:solidFill>
-                  <a:schemeClr val="accent5"/>
-                </a:solidFill>
-                <a:latin typeface="Calibri" pitchFamily="34" charset="0"/>
-                <a:ea typeface="Calibri" pitchFamily="34" charset="-122"/>
-                <a:cs typeface="Calibri" pitchFamily="34" charset="-120"/>
-              </a:rPr>
-              <a:t>  busca medida; pico com 3 em paralelo a medir</a:t>
-            </a:r>
-            <a:endParaRPr lang="en-US" sz="1050" dirty="0"/>
-          </a:p>
-        </p:txBody>
-      </p:sp>
-      <p:sp>
-        <p:nvSpPr>
-          <p:cNvPr id="30" name="Shape 28"/>
-          <p:cNvSpPr/>
-          <p:nvPr/>
-        </p:nvSpPr>
-        <p:spPr>
-          <a:xfrm>
-            <a:off x="4663440" y="1517904"/>
-            <a:ext cx="502920" cy="292608"/>
-          </a:xfrm>
-          <a:prstGeom prst="roundRect">
-            <a:avLst>
-              <a:gd name="adj" fmla="val 25000"/>
-            </a:avLst>
-          </a:prstGeom>
-          <a:solidFill>
-            <a:schemeClr val="accent2"/>
-          </a:solidFill>
-          <a:ln w="12700">
-            <a:solidFill>
-              <a:schemeClr val="accent2"/>
-            </a:solidFill>
-            <a:prstDash val="solid"/>
-          </a:ln>
-        </p:spPr>
-      </p:sp>
-      <p:sp>
-        <p:nvSpPr>
-          <p:cNvPr id="31" name="Text 29"/>
-          <p:cNvSpPr txBox="1"/>
-          <p:nvPr/>
-        </p:nvSpPr>
-        <p:spPr>
-          <a:xfrm>
-            <a:off x="4663440" y="1517904"/>
-            <a:ext cx="502920" cy="292608"/>
-          </a:xfrm>
-          <a:prstGeom prst="rect">
-            <a:avLst/>
-          </a:prstGeom>
-          <a:noFill/>
-          <a:ln/>
-        </p:spPr>
-        <p:txBody>
-          <a:bodyPr wrap="square" lIns="0" tIns="0" rIns="0" bIns="0" rtlCol="0" anchor="ctr"/>
-          <a:lstStyle/>
-          <a:p>
-            <a:pPr algn="ctr" indent="0" marL="0">
-              <a:buNone/>
-            </a:pPr>
-            <a:r>
-              <a:rPr lang="en-US" sz="1100" b="1" dirty="0">
-                <a:solidFill>
-                  <a:schemeClr val="bg1"/>
-                </a:solidFill>
-                <a:latin typeface="Calibri" pitchFamily="34" charset="0"/>
-                <a:ea typeface="Calibri" pitchFamily="34" charset="-122"/>
-                <a:cs typeface="Calibri" pitchFamily="34" charset="-120"/>
-              </a:rPr>
-              <a:t>R10</a:t>
-            </a:r>
-            <a:endParaRPr lang="en-US" sz="1100" dirty="0"/>
-          </a:p>
-        </p:txBody>
-      </p:sp>
-      <p:sp>
-        <p:nvSpPr>
-          <p:cNvPr id="32" name="Text 30"/>
-          <p:cNvSpPr txBox="1"/>
-          <p:nvPr/>
-        </p:nvSpPr>
-        <p:spPr>
-          <a:xfrm>
-            <a:off x="5257800" y="1499616"/>
-            <a:ext cx="3520440" cy="347472"/>
-          </a:xfrm>
-          <a:prstGeom prst="rect">
-            <a:avLst/>
-          </a:prstGeom>
-          <a:noFill/>
-          <a:ln/>
-        </p:spPr>
-        <p:txBody>
-          <a:bodyPr wrap="square" lIns="0" tIns="0" rIns="0" bIns="0" rtlCol="0" anchor="ctr"/>
-          <a:lstStyle/>
-          <a:p>
-            <a:pPr indent="0" marL="0">
-              <a:buNone/>
-            </a:pPr>
-            <a:r>
-              <a:rPr lang="en-US" sz="1050" b="1" dirty="0">
-                <a:solidFill>
-                  <a:schemeClr val="tx1"/>
-                </a:solidFill>
-                <a:latin typeface="Calibri" pitchFamily="34" charset="0"/>
-                <a:ea typeface="Calibri" pitchFamily="34" charset="-122"/>
-                <a:cs typeface="Calibri" pitchFamily="34" charset="-120"/>
-              </a:rPr>
-              <a:t>Custo em cota e dinheiro</a:t>
-            </a:r>
-            <a:pPr indent="0" marL="0">
-              <a:buNone/>
-            </a:pPr>
-            <a:r>
-              <a:rPr lang="en-US" sz="1050" dirty="0">
-                <a:solidFill>
-                  <a:schemeClr val="accent5"/>
-                </a:solidFill>
-                <a:latin typeface="Calibri" pitchFamily="34" charset="0"/>
-                <a:ea typeface="Calibri" pitchFamily="34" charset="-122"/>
-                <a:cs typeface="Calibri" pitchFamily="34" charset="-120"/>
-              </a:rPr>
-              <a:t>  consumos em cota e US$</a:t>
-            </a:r>
-            <a:endParaRPr lang="en-US" sz="1050" dirty="0"/>
-          </a:p>
-        </p:txBody>
-      </p:sp>
-      <p:sp>
-        <p:nvSpPr>
-          <p:cNvPr id="33" name="Shape 31"/>
-          <p:cNvSpPr/>
-          <p:nvPr/>
-        </p:nvSpPr>
-        <p:spPr>
-          <a:xfrm>
-            <a:off x="4663440" y="1947672"/>
-            <a:ext cx="502920" cy="292608"/>
-          </a:xfrm>
-          <a:prstGeom prst="roundRect">
-            <a:avLst>
-              <a:gd name="adj" fmla="val 25000"/>
-            </a:avLst>
-          </a:prstGeom>
-          <a:solidFill>
-            <a:schemeClr val="accent2"/>
-          </a:solidFill>
-          <a:ln w="12700">
-            <a:solidFill>
-              <a:schemeClr val="accent2"/>
-            </a:solidFill>
-            <a:prstDash val="solid"/>
-          </a:ln>
-        </p:spPr>
-      </p:sp>
-      <p:sp>
-        <p:nvSpPr>
-          <p:cNvPr id="34" name="Text 32"/>
-          <p:cNvSpPr txBox="1"/>
-          <p:nvPr/>
-        </p:nvSpPr>
-        <p:spPr>
-          <a:xfrm>
-            <a:off x="4663440" y="1947672"/>
-            <a:ext cx="502920" cy="292608"/>
-          </a:xfrm>
-          <a:prstGeom prst="rect">
-            <a:avLst/>
-          </a:prstGeom>
-          <a:noFill/>
-          <a:ln/>
-        </p:spPr>
-        <p:txBody>
-          <a:bodyPr wrap="square" lIns="0" tIns="0" rIns="0" bIns="0" rtlCol="0" anchor="ctr"/>
-          <a:lstStyle/>
-          <a:p>
-            <a:pPr algn="ctr" indent="0" marL="0">
-              <a:buNone/>
-            </a:pPr>
-            <a:r>
-              <a:rPr lang="en-US" sz="1100" b="1" dirty="0">
-                <a:solidFill>
-                  <a:schemeClr val="bg1"/>
-                </a:solidFill>
-                <a:latin typeface="Calibri" pitchFamily="34" charset="0"/>
-                <a:ea typeface="Calibri" pitchFamily="34" charset="-122"/>
-                <a:cs typeface="Calibri" pitchFamily="34" charset="-120"/>
-              </a:rPr>
-              <a:t>R11</a:t>
-            </a:r>
-            <a:endParaRPr lang="en-US" sz="1100" dirty="0"/>
-          </a:p>
-        </p:txBody>
-      </p:sp>
-      <p:sp>
-        <p:nvSpPr>
-          <p:cNvPr id="35" name="Text 33"/>
-          <p:cNvSpPr txBox="1"/>
-          <p:nvPr/>
-        </p:nvSpPr>
-        <p:spPr>
-          <a:xfrm>
-            <a:off x="5257800" y="1929384"/>
-            <a:ext cx="3520440" cy="347472"/>
-          </a:xfrm>
-          <a:prstGeom prst="rect">
-            <a:avLst/>
-          </a:prstGeom>
-          <a:noFill/>
-          <a:ln/>
-        </p:spPr>
-        <p:txBody>
-          <a:bodyPr wrap="square" lIns="0" tIns="0" rIns="0" bIns="0" rtlCol="0" anchor="ctr"/>
-          <a:lstStyle/>
-          <a:p>
-            <a:pPr indent="0" marL="0">
-              <a:buNone/>
-            </a:pPr>
-            <a:r>
-              <a:rPr lang="en-US" sz="1050" b="1" dirty="0">
-                <a:solidFill>
-                  <a:schemeClr val="tx1"/>
-                </a:solidFill>
-                <a:latin typeface="Calibri" pitchFamily="34" charset="0"/>
-                <a:ea typeface="Calibri" pitchFamily="34" charset="-122"/>
-                <a:cs typeface="Calibri" pitchFamily="34" charset="-120"/>
-              </a:rPr>
-              <a:t>Nada escrito fora do projeto</a:t>
-            </a:r>
-            <a:pPr indent="0" marL="0">
-              <a:buNone/>
-            </a:pPr>
-            <a:r>
-              <a:rPr lang="en-US" sz="1050" dirty="0">
-                <a:solidFill>
-                  <a:schemeClr val="accent5"/>
-                </a:solidFill>
-                <a:latin typeface="Calibri" pitchFamily="34" charset="0"/>
-                <a:ea typeface="Calibri" pitchFamily="34" charset="-122"/>
-                <a:cs typeface="Calibri" pitchFamily="34" charset="-120"/>
-              </a:rPr>
-              <a:t>  confinamento + sandbox</a:t>
-            </a:r>
-            <a:endParaRPr lang="en-US" sz="1050" dirty="0"/>
-          </a:p>
-        </p:txBody>
-      </p:sp>
-      <p:sp>
-        <p:nvSpPr>
-          <p:cNvPr id="36" name="Shape 34"/>
-          <p:cNvSpPr/>
-          <p:nvPr/>
-        </p:nvSpPr>
-        <p:spPr>
-          <a:xfrm>
-            <a:off x="4663440" y="2377440"/>
-            <a:ext cx="502920" cy="292608"/>
-          </a:xfrm>
-          <a:prstGeom prst="roundRect">
-            <a:avLst>
-              <a:gd name="adj" fmla="val 25000"/>
-            </a:avLst>
-          </a:prstGeom>
-          <a:solidFill>
-            <a:schemeClr val="accent2"/>
-          </a:solidFill>
-          <a:ln w="12700">
-            <a:solidFill>
-              <a:schemeClr val="accent2"/>
-            </a:solidFill>
-            <a:prstDash val="solid"/>
-          </a:ln>
-        </p:spPr>
-      </p:sp>
-      <p:sp>
-        <p:nvSpPr>
-          <p:cNvPr id="37" name="Text 35"/>
-          <p:cNvSpPr txBox="1"/>
-          <p:nvPr/>
-        </p:nvSpPr>
-        <p:spPr>
-          <a:xfrm>
-            <a:off x="4663440" y="2377440"/>
-            <a:ext cx="502920" cy="292608"/>
-          </a:xfrm>
-          <a:prstGeom prst="rect">
-            <a:avLst/>
-          </a:prstGeom>
-          <a:noFill/>
-          <a:ln/>
-        </p:spPr>
-        <p:txBody>
-          <a:bodyPr wrap="square" lIns="0" tIns="0" rIns="0" bIns="0" rtlCol="0" anchor="ctr"/>
-          <a:lstStyle/>
-          <a:p>
-            <a:pPr algn="ctr" indent="0" marL="0">
-              <a:buNone/>
-            </a:pPr>
-            <a:r>
-              <a:rPr lang="en-US" sz="1100" b="1" dirty="0">
-                <a:solidFill>
-                  <a:schemeClr val="bg1"/>
-                </a:solidFill>
-                <a:latin typeface="Calibri" pitchFamily="34" charset="0"/>
-                <a:ea typeface="Calibri" pitchFamily="34" charset="-122"/>
-                <a:cs typeface="Calibri" pitchFamily="34" charset="-120"/>
-              </a:rPr>
-              <a:t>R12</a:t>
-            </a:r>
-            <a:endParaRPr lang="en-US" sz="1100" dirty="0"/>
-          </a:p>
-        </p:txBody>
-      </p:sp>
-      <p:sp>
-        <p:nvSpPr>
-          <p:cNvPr id="38" name="Text 36"/>
-          <p:cNvSpPr txBox="1"/>
-          <p:nvPr/>
-        </p:nvSpPr>
-        <p:spPr>
-          <a:xfrm>
-            <a:off x="5257800" y="2359152"/>
-            <a:ext cx="3520440" cy="347472"/>
-          </a:xfrm>
-          <a:prstGeom prst="rect">
-            <a:avLst/>
-          </a:prstGeom>
-          <a:noFill/>
-          <a:ln/>
-        </p:spPr>
-        <p:txBody>
-          <a:bodyPr wrap="square" lIns="0" tIns="0" rIns="0" bIns="0" rtlCol="0" anchor="ctr"/>
-          <a:lstStyle/>
-          <a:p>
-            <a:pPr indent="0" marL="0">
-              <a:buNone/>
-            </a:pPr>
-            <a:r>
-              <a:rPr lang="en-US" sz="1050" b="1" dirty="0">
-                <a:solidFill>
-                  <a:schemeClr val="tx1"/>
-                </a:solidFill>
-                <a:latin typeface="Calibri" pitchFamily="34" charset="0"/>
-                <a:ea typeface="Calibri" pitchFamily="34" charset="-122"/>
-                <a:cs typeface="Calibri" pitchFamily="34" charset="-120"/>
-              </a:rPr>
-              <a:t>Testes sem internet e sem cota</a:t>
-            </a:r>
-            <a:pPr indent="0" marL="0">
-              <a:buNone/>
-            </a:pPr>
-            <a:r>
-              <a:rPr lang="en-US" sz="1050" dirty="0">
-                <a:solidFill>
-                  <a:schemeClr val="accent5"/>
-                </a:solidFill>
-                <a:latin typeface="Calibri" pitchFamily="34" charset="0"/>
-                <a:ea typeface="Calibri" pitchFamily="34" charset="-122"/>
-                <a:cs typeface="Calibri" pitchFamily="34" charset="-120"/>
-              </a:rPr>
-              <a:t>  teste do marco E2</a:t>
-            </a:r>
-            <a:endParaRPr lang="en-US" sz="1050" dirty="0"/>
-          </a:p>
-        </p:txBody>
-      </p:sp>
-      <p:sp>
-        <p:nvSpPr>
-          <p:cNvPr id="39" name="Shape 37"/>
-          <p:cNvSpPr/>
-          <p:nvPr/>
-        </p:nvSpPr>
-        <p:spPr>
-          <a:xfrm>
-            <a:off x="4663440" y="2807208"/>
-            <a:ext cx="502920" cy="292608"/>
-          </a:xfrm>
-          <a:prstGeom prst="roundRect">
-            <a:avLst>
-              <a:gd name="adj" fmla="val 25000"/>
-            </a:avLst>
-          </a:prstGeom>
-          <a:solidFill>
-            <a:schemeClr val="accent2"/>
-          </a:solidFill>
-          <a:ln w="12700">
-            <a:solidFill>
-              <a:schemeClr val="accent2"/>
-            </a:solidFill>
-            <a:prstDash val="solid"/>
-          </a:ln>
-        </p:spPr>
-      </p:sp>
-      <p:sp>
-        <p:nvSpPr>
-          <p:cNvPr id="40" name="Text 38"/>
-          <p:cNvSpPr txBox="1"/>
-          <p:nvPr/>
-        </p:nvSpPr>
-        <p:spPr>
-          <a:xfrm>
-            <a:off x="4663440" y="2807208"/>
-            <a:ext cx="502920" cy="292608"/>
-          </a:xfrm>
-          <a:prstGeom prst="rect">
-            <a:avLst/>
-          </a:prstGeom>
-          <a:noFill/>
-          <a:ln/>
-        </p:spPr>
-        <p:txBody>
-          <a:bodyPr wrap="square" lIns="0" tIns="0" rIns="0" bIns="0" rtlCol="0" anchor="ctr"/>
-          <a:lstStyle/>
-          <a:p>
-            <a:pPr algn="ctr" indent="0" marL="0">
-              <a:buNone/>
-            </a:pPr>
-            <a:r>
-              <a:rPr lang="en-US" sz="1100" b="1" dirty="0">
-                <a:solidFill>
-                  <a:schemeClr val="bg1"/>
-                </a:solidFill>
-                <a:latin typeface="Calibri" pitchFamily="34" charset="0"/>
-                <a:ea typeface="Calibri" pitchFamily="34" charset="-122"/>
-                <a:cs typeface="Calibri" pitchFamily="34" charset="-120"/>
-              </a:rPr>
-              <a:t>R13</a:t>
-            </a:r>
-            <a:endParaRPr lang="en-US" sz="1100" dirty="0"/>
-          </a:p>
-        </p:txBody>
-      </p:sp>
-      <p:sp>
-        <p:nvSpPr>
-          <p:cNvPr id="41" name="Text 39"/>
-          <p:cNvSpPr txBox="1"/>
-          <p:nvPr/>
-        </p:nvSpPr>
-        <p:spPr>
-          <a:xfrm>
-            <a:off x="5257800" y="2788920"/>
-            <a:ext cx="3520440" cy="347472"/>
-          </a:xfrm>
-          <a:prstGeom prst="rect">
-            <a:avLst/>
-          </a:prstGeom>
-          <a:noFill/>
-          <a:ln/>
-        </p:spPr>
-        <p:txBody>
-          <a:bodyPr wrap="square" lIns="0" tIns="0" rIns="0" bIns="0" rtlCol="0" anchor="ctr"/>
-          <a:lstStyle/>
-          <a:p>
-            <a:pPr indent="0" marL="0">
-              <a:buNone/>
-            </a:pPr>
-            <a:r>
-              <a:rPr lang="en-US" sz="1050" b="1" dirty="0">
-                <a:solidFill>
-                  <a:schemeClr val="tx1"/>
-                </a:solidFill>
-                <a:latin typeface="Calibri" pitchFamily="34" charset="0"/>
-                <a:ea typeface="Calibri" pitchFamily="34" charset="-122"/>
-                <a:cs typeface="Calibri" pitchFamily="34" charset="-120"/>
-              </a:rPr>
-              <a:t>Queda isolada, sem perda</a:t>
-            </a:r>
-            <a:pPr indent="0" marL="0">
-              <a:buNone/>
-            </a:pPr>
-            <a:r>
-              <a:rPr lang="en-US" sz="1050" dirty="0">
-                <a:solidFill>
-                  <a:schemeClr val="accent5"/>
-                </a:solidFill>
-                <a:latin typeface="Calibri" pitchFamily="34" charset="0"/>
-                <a:ea typeface="Calibri" pitchFamily="34" charset="-122"/>
-                <a:cs typeface="Calibri" pitchFamily="34" charset="-120"/>
-              </a:rPr>
-              <a:t>  teste do marco E5</a:t>
-            </a:r>
-            <a:endParaRPr lang="en-US" sz="1050" dirty="0"/>
-          </a:p>
-        </p:txBody>
-      </p:sp>
-      <p:sp>
-        <p:nvSpPr>
-          <p:cNvPr id="42" name="Shape 40"/>
-          <p:cNvSpPr/>
+          <p:cNvPr id="43" name="Text 41"/>
+          <p:cNvSpPr txBox="1"/>
           <p:nvPr/>
         </p:nvSpPr>
         <p:spPr>
@@ -11235,33 +11262,6 @@
             <a:off x="4663440" y="3236976"/>
             <a:ext cx="502920" cy="292608"/>
           </a:xfrm>
-          <a:prstGeom prst="roundRect">
-            <a:avLst>
-              <a:gd name="adj" fmla="val 25000"/>
-            </a:avLst>
-          </a:prstGeom>
-          <a:solidFill>
-            <a:schemeClr val="accent2"/>
-          </a:solidFill>
-          <a:ln w="12700">
-            <a:solidFill>
-              <a:schemeClr val="accent2"/>
-            </a:solidFill>
-            <a:prstDash val="solid"/>
-          </a:ln>
-        </p:spPr>
-      </p:sp>
-      <p:sp>
-        <p:nvSpPr>
-          <p:cNvPr id="43" name="Text 41"/>
-          <p:cNvSpPr txBox="1"/>
-          <p:nvPr/>
-        </p:nvSpPr>
-        <p:spPr>
-          <a:xfrm>
-            <a:off x="4663440" y="3236976"/>
-            <a:ext cx="502920" cy="292608"/>
-          </a:xfrm>
           <a:prstGeom prst="rect">
             <a:avLst/>
           </a:prstGeom>
@@ -11337,7 +11337,7 @@
                 <a:ea typeface="Calibri" pitchFamily="34" charset="-122"/>
                 <a:cs typeface="Calibri" pitchFamily="34" charset="-120"/>
               </a:rPr>
-              <a:t>  teto que nunca corta no meio</a:t>
+              <a:t>  regra do teto testada; o piloto (E7) para por gasto acumulado</a:t>
             </a:r>
             <a:endParaRPr lang="en-US" sz="1050" dirty="0"/>
           </a:p>
@@ -11575,18 +11575,18 @@
       </p:sp>
       <p:sp>
         <p:nvSpPr>
-          <p:cNvPr id="3" name="pend-0"/>
+          <p:cNvPr id="3" name="pend-col-0"/>
           <p:cNvSpPr/>
           <p:nvPr/>
         </p:nvSpPr>
         <p:spPr>
           <a:xfrm>
-            <a:off x="457200" y="1097280"/>
-            <a:ext cx="8229600" cy="566928"/>
+            <a:off x="457200" y="1005840"/>
+            <a:ext cx="4023360" cy="3657600"/>
           </a:xfrm>
           <a:prstGeom prst="roundRect">
             <a:avLst>
-              <a:gd name="adj" fmla="val 12903"/>
+              <a:gd name="adj" fmla="val 2000"/>
             </a:avLst>
           </a:prstGeom>
           <a:solidFill>
@@ -11608,8 +11608,8 @@
         </p:nvSpPr>
         <p:spPr>
           <a:xfrm>
-            <a:off x="594360" y="1207008"/>
-            <a:ext cx="548640" cy="347472"/>
+            <a:off x="594360" y="1097280"/>
+            <a:ext cx="3749040" cy="3474720"/>
           </a:xfrm>
           <a:prstGeom prst="rect">
             <a:avLst/>
@@ -11625,7 +11625,7 @@
               <a:buNone/>
             </a:pPr>
             <a:r>
-              <a:rPr lang="en-US" sz="1600" b="1" dirty="0">
+              <a:rPr lang="en-US" sz="1200" b="1" dirty="0">
                 <a:solidFill>
                   <a:schemeClr val="accent3"/>
                 </a:solidFill>
@@ -11635,36 +11635,18 @@
               </a:rPr>
               <a:t>E1</a:t>
             </a:r>
-            <a:endParaRPr lang="en-US" sz="1600" dirty="0"/>
-          </a:p>
-        </p:txBody>
-      </p:sp>
-      <p:sp>
-        <p:nvSpPr>
-          <p:cNvPr id="5" name="Text 3"/>
-          <p:cNvSpPr txBox="1"/>
-          <p:nvPr/>
-        </p:nvSpPr>
-        <p:spPr>
-          <a:xfrm>
-            <a:off x="1234440" y="1170432"/>
-            <a:ext cx="7315200" cy="438912"/>
-          </a:xfrm>
-          <a:prstGeom prst="rect">
-            <a:avLst/>
-          </a:prstGeom>
-          <a:noFill/>
-          <a:ln/>
-        </p:spPr>
-        <p:txBody>
-          <a:bodyPr wrap="square" lIns="0" tIns="0" rIns="0" bIns="0" rtlCol="0" anchor="ctr"/>
-          <a:lstStyle/>
-          <a:p>
-            <a:pPr indent="0" marL="0">
-              <a:buNone/>
-            </a:pPr>
-            <a:r>
-              <a:rPr lang="en-US" sz="1200" dirty="0">
+            <a:endParaRPr lang="en-US" sz="1400" dirty="0"/>
+          </a:p>
+          <a:p>
+            <a:pPr marL="152400" indent="-152400">
+              <a:spcAft>
+                <a:spcPts val="200"/>
+              </a:spcAft>
+              <a:buSzPct val="100000"/>
+              <a:buChar char="•"/>
+            </a:pPr>
+            <a:r>
+              <a:rPr lang="en-US" sz="950" dirty="0">
                 <a:solidFill>
                   <a:schemeClr val="tx1"/>
                 </a:solidFill>
@@ -11674,24 +11656,210 @@
               </a:rPr>
               <a:t>Validar com o orientador a proposta dos cinco projetos de teste (FAB-105).</a:t>
             </a:r>
-            <a:endParaRPr lang="en-US" sz="1200" dirty="0"/>
-          </a:p>
-        </p:txBody>
-      </p:sp>
-      <p:sp>
-        <p:nvSpPr>
-          <p:cNvPr id="6" name="pend-1"/>
+            <a:endParaRPr lang="en-US" sz="1400" dirty="0"/>
+          </a:p>
+          <a:p>
+            <a:pPr indent="0" marL="0">
+              <a:spcBef>
+                <a:spcPts val="600"/>
+              </a:spcBef>
+              <a:buNone/>
+            </a:pPr>
+            <a:r>
+              <a:rPr lang="en-US" sz="1200" b="1" dirty="0">
+                <a:solidFill>
+                  <a:schemeClr val="accent3"/>
+                </a:solidFill>
+                <a:latin typeface="Calibri" pitchFamily="34" charset="0"/>
+                <a:ea typeface="Calibri" pitchFamily="34" charset="-122"/>
+                <a:cs typeface="Calibri" pitchFamily="34" charset="-120"/>
+              </a:rPr>
+              <a:t>E3</a:t>
+            </a:r>
+            <a:endParaRPr lang="en-US" sz="1400" dirty="0"/>
+          </a:p>
+          <a:p>
+            <a:pPr marL="152400" indent="-152400">
+              <a:spcAft>
+                <a:spcPts val="200"/>
+              </a:spcAft>
+              <a:buSzPct val="100000"/>
+              <a:buChar char="•"/>
+            </a:pPr>
+            <a:r>
+              <a:rPr lang="en-US" sz="950" dirty="0">
+                <a:solidFill>
+                  <a:schemeClr val="tx1"/>
+                </a:solidFill>
+                <a:latin typeface="Calibri" pitchFamily="34" charset="0"/>
+                <a:ea typeface="Calibri" pitchFamily="34" charset="-122"/>
+                <a:cs typeface="Calibri" pitchFamily="34" charset="-120"/>
+              </a:rPr>
+              <a:t>A medição do cache com a API por token depende de uma chave de acesso e foi deixada para depois do marco final.</a:t>
+            </a:r>
+            <a:endParaRPr lang="en-US" sz="1400" dirty="0"/>
+          </a:p>
+          <a:p>
+            <a:pPr indent="0" marL="0">
+              <a:spcBef>
+                <a:spcPts val="600"/>
+              </a:spcBef>
+              <a:buNone/>
+            </a:pPr>
+            <a:r>
+              <a:rPr lang="en-US" sz="1200" b="1" dirty="0">
+                <a:solidFill>
+                  <a:schemeClr val="accent3"/>
+                </a:solidFill>
+                <a:latin typeface="Calibri" pitchFamily="34" charset="0"/>
+                <a:ea typeface="Calibri" pitchFamily="34" charset="-122"/>
+                <a:cs typeface="Calibri" pitchFamily="34" charset="-120"/>
+              </a:rPr>
+              <a:t>E4</a:t>
+            </a:r>
+            <a:endParaRPr lang="en-US" sz="1400" dirty="0"/>
+          </a:p>
+          <a:p>
+            <a:pPr marL="152400" indent="-152400">
+              <a:spcAft>
+                <a:spcPts val="200"/>
+              </a:spcAft>
+              <a:buSzPct val="100000"/>
+              <a:buChar char="•"/>
+            </a:pPr>
+            <a:r>
+              <a:rPr lang="en-US" sz="950" dirty="0">
+                <a:solidFill>
+                  <a:schemeClr val="tx1"/>
+                </a:solidFill>
+                <a:latin typeface="Calibri" pitchFamily="34" charset="0"/>
+                <a:ea typeface="Calibri" pitchFamily="34" charset="-122"/>
+                <a:cs typeface="Calibri" pitchFamily="34" charset="-120"/>
+              </a:rPr>
+              <a:t>R1 (pedido → tarefas) está implementado; o teste com um pedido real de ponta a ponta acontece na validação (E8).</a:t>
+            </a:r>
+            <a:endParaRPr lang="en-US" sz="1400" dirty="0"/>
+          </a:p>
+          <a:p>
+            <a:pPr marL="152400" indent="-152400">
+              <a:spcAft>
+                <a:spcPts val="200"/>
+              </a:spcAft>
+              <a:buSzPct val="100000"/>
+              <a:buChar char="•"/>
+            </a:pPr>
+            <a:r>
+              <a:rPr lang="en-US" sz="950" dirty="0">
+                <a:solidFill>
+                  <a:schemeClr val="tx1"/>
+                </a:solidFill>
+                <a:latin typeface="Calibri" pitchFamily="34" charset="0"/>
+                <a:ea typeface="Calibri" pitchFamily="34" charset="-122"/>
+                <a:cs typeface="Calibri" pitchFamily="34" charset="-120"/>
+              </a:rPr>
+              <a:t>Escada de resposta, diagnóstico e teto de gasto são regras puras, prontas e testadas; nesta etapa nenhum laço automático ainda as chama — quem as encadeia é o teste do marco.</a:t>
+            </a:r>
+            <a:endParaRPr lang="en-US" sz="1400" dirty="0"/>
+          </a:p>
+          <a:p>
+            <a:pPr indent="0" marL="0">
+              <a:spcBef>
+                <a:spcPts val="600"/>
+              </a:spcBef>
+              <a:buNone/>
+            </a:pPr>
+            <a:r>
+              <a:rPr lang="en-US" sz="1200" b="1" dirty="0">
+                <a:solidFill>
+                  <a:schemeClr val="accent3"/>
+                </a:solidFill>
+                <a:latin typeface="Calibri" pitchFamily="34" charset="0"/>
+                <a:ea typeface="Calibri" pitchFamily="34" charset="-122"/>
+                <a:cs typeface="Calibri" pitchFamily="34" charset="-120"/>
+              </a:rPr>
+              <a:t>E5</a:t>
+            </a:r>
+            <a:endParaRPr lang="en-US" sz="1400" dirty="0"/>
+          </a:p>
+          <a:p>
+            <a:pPr marL="152400" indent="-152400">
+              <a:spcAft>
+                <a:spcPts val="200"/>
+              </a:spcAft>
+              <a:buSzPct val="100000"/>
+              <a:buChar char="•"/>
+            </a:pPr>
+            <a:r>
+              <a:rPr lang="en-US" sz="950" dirty="0">
+                <a:solidFill>
+                  <a:schemeClr val="tx1"/>
+                </a:solidFill>
+                <a:latin typeface="Calibri" pitchFamily="34" charset="0"/>
+                <a:ea typeface="Calibri" pitchFamily="34" charset="-122"/>
+                <a:cs typeface="Calibri" pitchFamily="34" charset="-120"/>
+              </a:rPr>
+              <a:t>Nesta etapa o lote e o saneamento são chamados pelo teste do marco; quem monta a rodada e enfileira sozinho é o piloto automático (E7).</a:t>
+            </a:r>
+            <a:endParaRPr lang="en-US" sz="1400" dirty="0"/>
+          </a:p>
+          <a:p>
+            <a:pPr marL="152400" indent="-152400">
+              <a:spcAft>
+                <a:spcPts val="200"/>
+              </a:spcAft>
+              <a:buSzPct val="100000"/>
+              <a:buChar char="•"/>
+            </a:pPr>
+            <a:r>
+              <a:rPr lang="en-US" sz="950" dirty="0">
+                <a:solidFill>
+                  <a:schemeClr val="tx1"/>
+                </a:solidFill>
+                <a:latin typeface="Calibri" pitchFamily="34" charset="0"/>
+                <a:ea typeface="Calibri" pitchFamily="34" charset="-122"/>
+                <a:cs typeface="Calibri" pitchFamily="34" charset="-120"/>
+              </a:rPr>
+              <a:t>O saneamento roda quando chamado, ainda não automaticamente na subida do sistema.</a:t>
+            </a:r>
+            <a:endParaRPr lang="en-US" sz="1400" dirty="0"/>
+          </a:p>
+          <a:p>
+            <a:pPr marL="152400" indent="-152400">
+              <a:spcAft>
+                <a:spcPts val="200"/>
+              </a:spcAft>
+              <a:buSzPct val="100000"/>
+              <a:buChar char="•"/>
+            </a:pPr>
+            <a:r>
+              <a:rPr lang="en-US" sz="950" dirty="0">
+                <a:solidFill>
+                  <a:schemeClr val="tx1"/>
+                </a:solidFill>
+                <a:latin typeface="Calibri" pitchFamily="34" charset="0"/>
+                <a:ea typeface="Calibri" pitchFamily="34" charset="-122"/>
+                <a:cs typeface="Calibri" pitchFamily="34" charset="-120"/>
+              </a:rPr>
+              <a:t>Medir o pico de memória com agentes em paralelo na máquina de 8 GB (R9).</a:t>
+            </a:r>
+            <a:endParaRPr lang="en-US" sz="1400" dirty="0"/>
+          </a:p>
+        </p:txBody>
+      </p:sp>
+      <p:sp>
+        <p:nvSpPr>
+          <p:cNvPr id="5" name="pend-col-1"/>
           <p:cNvSpPr/>
           <p:nvPr/>
         </p:nvSpPr>
         <p:spPr>
           <a:xfrm>
-            <a:off x="457200" y="1783080"/>
-            <a:ext cx="8229600" cy="566928"/>
+            <a:off x="4663440" y="1005840"/>
+            <a:ext cx="4023360" cy="3657600"/>
           </a:xfrm>
           <a:prstGeom prst="roundRect">
             <a:avLst>
-              <a:gd name="adj" fmla="val 12903"/>
+              <a:gd name="adj" fmla="val 2000"/>
             </a:avLst>
           </a:prstGeom>
           <a:solidFill>
@@ -11707,14 +11875,14 @@
       </p:sp>
       <p:sp>
         <p:nvSpPr>
-          <p:cNvPr id="7" name="Text 5"/>
-          <p:cNvSpPr txBox="1"/>
-          <p:nvPr/>
-        </p:nvSpPr>
-        <p:spPr>
-          <a:xfrm>
-            <a:off x="594360" y="1892808"/>
-            <a:ext cx="548640" cy="347472"/>
+          <p:cNvPr id="6" name="Text 4"/>
+          <p:cNvSpPr txBox="1"/>
+          <p:nvPr/>
+        </p:nvSpPr>
+        <p:spPr>
+          <a:xfrm>
+            <a:off x="4800600" y="1097280"/>
+            <a:ext cx="3749040" cy="3474720"/>
           </a:xfrm>
           <a:prstGeom prst="rect">
             <a:avLst/>
@@ -11730,7 +11898,7 @@
               <a:buNone/>
             </a:pPr>
             <a:r>
-              <a:rPr lang="en-US" sz="1600" b="1" dirty="0">
+              <a:rPr lang="en-US" sz="1200" b="1" dirty="0">
                 <a:solidFill>
                   <a:schemeClr val="accent3"/>
                 </a:solidFill>
@@ -11738,38 +11906,20 @@
                 <a:ea typeface="Calibri" pitchFamily="34" charset="-122"/>
                 <a:cs typeface="Calibri" pitchFamily="34" charset="-120"/>
               </a:rPr>
-              <a:t>E3</a:t>
-            </a:r>
-            <a:endParaRPr lang="en-US" sz="1600" dirty="0"/>
-          </a:p>
-        </p:txBody>
-      </p:sp>
-      <p:sp>
-        <p:nvSpPr>
-          <p:cNvPr id="8" name="Text 6"/>
-          <p:cNvSpPr txBox="1"/>
-          <p:nvPr/>
-        </p:nvSpPr>
-        <p:spPr>
-          <a:xfrm>
-            <a:off x="1234440" y="1856232"/>
-            <a:ext cx="7315200" cy="438912"/>
-          </a:xfrm>
-          <a:prstGeom prst="rect">
-            <a:avLst/>
-          </a:prstGeom>
-          <a:noFill/>
-          <a:ln/>
-        </p:spPr>
-        <p:txBody>
-          <a:bodyPr wrap="square" lIns="0" tIns="0" rIns="0" bIns="0" rtlCol="0" anchor="ctr"/>
-          <a:lstStyle/>
-          <a:p>
-            <a:pPr indent="0" marL="0">
-              <a:buNone/>
-            </a:pPr>
-            <a:r>
-              <a:rPr lang="en-US" sz="1200" dirty="0">
+              <a:t>E6</a:t>
+            </a:r>
+            <a:endParaRPr lang="en-US" sz="1400" dirty="0"/>
+          </a:p>
+          <a:p>
+            <a:pPr marL="152400" indent="-152400">
+              <a:spcAft>
+                <a:spcPts val="200"/>
+              </a:spcAft>
+              <a:buSzPct val="100000"/>
+              <a:buChar char="•"/>
+            </a:pPr>
+            <a:r>
+              <a:rPr lang="en-US" sz="950" dirty="0">
                 <a:solidFill>
                   <a:schemeClr val="tx1"/>
                 </a:solidFill>
@@ -11777,65 +11927,61 @@
                 <a:ea typeface="Calibri" pitchFamily="34" charset="-122"/>
                 <a:cs typeface="Calibri" pitchFamily="34" charset="-120"/>
               </a:rPr>
-              <a:t>A medição do cache com a API por token depende de uma chave de acesso e foi deixada para depois do marco final.</a:t>
-            </a:r>
-            <a:endParaRPr lang="en-US" sz="1200" dirty="0"/>
-          </a:p>
-        </p:txBody>
-      </p:sp>
-      <p:sp>
-        <p:nvSpPr>
-          <p:cNvPr id="9" name="pend-2"/>
-          <p:cNvSpPr/>
-          <p:nvPr/>
-        </p:nvSpPr>
-        <p:spPr>
-          <a:xfrm>
-            <a:off x="457200" y="2468880"/>
-            <a:ext cx="8229600" cy="566928"/>
-          </a:xfrm>
-          <a:prstGeom prst="roundRect">
-            <a:avLst>
-              <a:gd name="adj" fmla="val 12903"/>
-            </a:avLst>
-          </a:prstGeom>
-          <a:solidFill>
-            <a:schemeClr val="bg2"/>
-          </a:solidFill>
-          <a:ln w="12700">
-            <a:solidFill>
-              <a:schemeClr val="bg2"/>
-            </a:solidFill>
-            <a:prstDash val="solid"/>
-          </a:ln>
-        </p:spPr>
-      </p:sp>
-      <p:sp>
-        <p:nvSpPr>
-          <p:cNvPr id="10" name="Text 8"/>
-          <p:cNvSpPr txBox="1"/>
-          <p:nvPr/>
-        </p:nvSpPr>
-        <p:spPr>
-          <a:xfrm>
-            <a:off x="594360" y="2578608"/>
-            <a:ext cx="548640" cy="347472"/>
-          </a:xfrm>
-          <a:prstGeom prst="rect">
-            <a:avLst/>
-          </a:prstGeom>
-          <a:noFill/>
-          <a:ln/>
-        </p:spPr>
-        <p:txBody>
-          <a:bodyPr wrap="square" lIns="0" tIns="0" rIns="0" bIns="0" rtlCol="0" anchor="t"/>
-          <a:lstStyle/>
-          <a:p>
-            <a:pPr indent="0" marL="0">
-              <a:buNone/>
-            </a:pPr>
-            <a:r>
-              <a:rPr lang="en-US" sz="1600" b="1" dirty="0">
+              <a:t>Marco bloqueado: nesta etapa a memória ainda não está ligada ao despacho; na E7 o despacho passa a anexar o bloco, mas a fila ainda o descarta ao montar a mensagem (ajuste pequeno, já localizado).</a:t>
+            </a:r>
+            <a:endParaRPr lang="en-US" sz="1400" dirty="0"/>
+          </a:p>
+          <a:p>
+            <a:pPr marL="152400" indent="-152400">
+              <a:spcAft>
+                <a:spcPts val="200"/>
+              </a:spcAft>
+              <a:buSzPct val="100000"/>
+              <a:buChar char="•"/>
+            </a:pPr>
+            <a:r>
+              <a:rPr lang="en-US" sz="950" dirty="0">
+                <a:solidFill>
+                  <a:schemeClr val="tx1"/>
+                </a:solidFill>
+                <a:latin typeface="Calibri" pitchFamily="34" charset="0"/>
+                <a:ea typeface="Calibri" pitchFamily="34" charset="-122"/>
+                <a:cs typeface="Calibri" pitchFamily="34" charset="-120"/>
+              </a:rPr>
+              <a:t>A ingestão ainda não é disparada sozinha a cada mudança do histórico; nesta etapa quem a chama são os testes.</a:t>
+            </a:r>
+            <a:endParaRPr lang="en-US" sz="1400" dirty="0"/>
+          </a:p>
+          <a:p>
+            <a:pPr marL="152400" indent="-152400">
+              <a:spcAft>
+                <a:spcPts val="200"/>
+              </a:spcAft>
+              <a:buSzPct val="100000"/>
+              <a:buChar char="•"/>
+            </a:pPr>
+            <a:r>
+              <a:rPr lang="en-US" sz="950" dirty="0">
+                <a:solidFill>
+                  <a:schemeClr val="tx1"/>
+                </a:solidFill>
+                <a:latin typeface="Calibri" pitchFamily="34" charset="0"/>
+                <a:ea typeface="Calibri" pitchFamily="34" charset="-122"/>
+                <a:cs typeface="Calibri" pitchFamily="34" charset="-120"/>
+              </a:rPr>
+              <a:t>Medir o pico de memória com agentes em paralelo na máquina de 8 GB (R9).</a:t>
+            </a:r>
+            <a:endParaRPr lang="en-US" sz="1400" dirty="0"/>
+          </a:p>
+          <a:p>
+            <a:pPr indent="0" marL="0">
+              <a:spcBef>
+                <a:spcPts val="600"/>
+              </a:spcBef>
+              <a:buNone/>
+            </a:pPr>
+            <a:r>
+              <a:rPr lang="en-US" sz="1200" b="1" dirty="0">
                 <a:solidFill>
                   <a:schemeClr val="accent3"/>
                 </a:solidFill>
@@ -11843,38 +11989,20 @@
                 <a:ea typeface="Calibri" pitchFamily="34" charset="-122"/>
                 <a:cs typeface="Calibri" pitchFamily="34" charset="-120"/>
               </a:rPr>
-              <a:t>E4</a:t>
-            </a:r>
-            <a:endParaRPr lang="en-US" sz="1600" dirty="0"/>
-          </a:p>
-        </p:txBody>
-      </p:sp>
-      <p:sp>
-        <p:nvSpPr>
-          <p:cNvPr id="11" name="Text 9"/>
-          <p:cNvSpPr txBox="1"/>
-          <p:nvPr/>
-        </p:nvSpPr>
-        <p:spPr>
-          <a:xfrm>
-            <a:off x="1234440" y="2542032"/>
-            <a:ext cx="7315200" cy="438912"/>
-          </a:xfrm>
-          <a:prstGeom prst="rect">
-            <a:avLst/>
-          </a:prstGeom>
-          <a:noFill/>
-          <a:ln/>
-        </p:spPr>
-        <p:txBody>
-          <a:bodyPr wrap="square" lIns="0" tIns="0" rIns="0" bIns="0" rtlCol="0" anchor="ctr"/>
-          <a:lstStyle/>
-          <a:p>
-            <a:pPr indent="0" marL="0">
-              <a:buNone/>
-            </a:pPr>
-            <a:r>
-              <a:rPr lang="en-US" sz="1200" dirty="0">
+              <a:t>E7</a:t>
+            </a:r>
+            <a:endParaRPr lang="en-US" sz="1400" dirty="0"/>
+          </a:p>
+          <a:p>
+            <a:pPr marL="152400" indent="-152400">
+              <a:spcAft>
+                <a:spcPts val="200"/>
+              </a:spcAft>
+              <a:buSzPct val="100000"/>
+              <a:buChar char="•"/>
+            </a:pPr>
+            <a:r>
+              <a:rPr lang="en-US" sz="950" dirty="0">
                 <a:solidFill>
                   <a:schemeClr val="tx1"/>
                 </a:solidFill>
@@ -11882,104 +12010,20 @@
                 <a:ea typeface="Calibri" pitchFamily="34" charset="-122"/>
                 <a:cs typeface="Calibri" pitchFamily="34" charset="-120"/>
               </a:rPr>
-              <a:t>R1 (pedido → tarefas) está implementado; o teste com um pedido real de ponta a ponta acontece na validação (E8).</a:t>
-            </a:r>
-            <a:endParaRPr lang="en-US" sz="1200" dirty="0"/>
-          </a:p>
-        </p:txBody>
-      </p:sp>
-      <p:sp>
-        <p:nvSpPr>
-          <p:cNvPr id="12" name="pend-3"/>
-          <p:cNvSpPr/>
-          <p:nvPr/>
-        </p:nvSpPr>
-        <p:spPr>
-          <a:xfrm>
-            <a:off x="457200" y="3154680"/>
-            <a:ext cx="8229600" cy="566928"/>
-          </a:xfrm>
-          <a:prstGeom prst="roundRect">
-            <a:avLst>
-              <a:gd name="adj" fmla="val 12903"/>
-            </a:avLst>
-          </a:prstGeom>
-          <a:solidFill>
-            <a:schemeClr val="bg2"/>
-          </a:solidFill>
-          <a:ln w="12700">
-            <a:solidFill>
-              <a:schemeClr val="bg2"/>
-            </a:solidFill>
-            <a:prstDash val="solid"/>
-          </a:ln>
-        </p:spPr>
-      </p:sp>
-      <p:sp>
-        <p:nvSpPr>
-          <p:cNvPr id="13" name="Text 11"/>
-          <p:cNvSpPr txBox="1"/>
-          <p:nvPr/>
-        </p:nvSpPr>
-        <p:spPr>
-          <a:xfrm>
-            <a:off x="594360" y="3264408"/>
-            <a:ext cx="548640" cy="347472"/>
-          </a:xfrm>
-          <a:prstGeom prst="rect">
-            <a:avLst/>
-          </a:prstGeom>
-          <a:noFill/>
-          <a:ln/>
-        </p:spPr>
-        <p:txBody>
-          <a:bodyPr wrap="square" lIns="0" tIns="0" rIns="0" bIns="0" rtlCol="0" anchor="t"/>
-          <a:lstStyle/>
-          <a:p>
-            <a:pPr indent="0" marL="0">
-              <a:buNone/>
-            </a:pPr>
-            <a:r>
-              <a:rPr lang="en-US" sz="1600" b="1" dirty="0">
-                <a:solidFill>
-                  <a:schemeClr val="accent3"/>
-                </a:solidFill>
-                <a:latin typeface="Calibri" pitchFamily="34" charset="0"/>
-                <a:ea typeface="Calibri" pitchFamily="34" charset="-122"/>
-                <a:cs typeface="Calibri" pitchFamily="34" charset="-120"/>
-              </a:rPr>
-              <a:t>E6</a:t>
-            </a:r>
-            <a:endParaRPr lang="en-US" sz="1600" dirty="0"/>
-          </a:p>
-        </p:txBody>
-      </p:sp>
-      <p:sp>
-        <p:nvSpPr>
-          <p:cNvPr id="14" name="Text 12"/>
-          <p:cNvSpPr txBox="1"/>
-          <p:nvPr/>
-        </p:nvSpPr>
-        <p:spPr>
-          <a:xfrm>
-            <a:off x="1234440" y="3227832"/>
-            <a:ext cx="7315200" cy="438912"/>
-          </a:xfrm>
-          <a:prstGeom prst="rect">
-            <a:avLst/>
-          </a:prstGeom>
-          <a:noFill/>
-          <a:ln/>
-        </p:spPr>
-        <p:txBody>
-          <a:bodyPr wrap="square" lIns="0" tIns="0" rIns="0" bIns="0" rtlCol="0" anchor="ctr"/>
-          <a:lstStyle/>
-          <a:p>
-            <a:pPr indent="0" marL="0">
-              <a:buNone/>
-            </a:pPr>
-            <a:r>
-              <a:rPr lang="en-US" sz="1200" dirty="0">
+              <a:t>Ligar os eventos de mudança de estado e de volta: o motor ainda não os emite, então a tela os recebe só nos testes.</a:t>
+            </a:r>
+            <a:endParaRPr lang="en-US" sz="1400" dirty="0"/>
+          </a:p>
+          <a:p>
+            <a:pPr marL="152400" indent="-152400">
+              <a:spcAft>
+                <a:spcPts val="200"/>
+              </a:spcAft>
+              <a:buSzPct val="100000"/>
+              <a:buChar char="•"/>
+            </a:pPr>
+            <a:r>
+              <a:rPr lang="en-US" sz="950" dirty="0">
                 <a:solidFill>
                   <a:schemeClr val="tx1"/>
                 </a:solidFill>
@@ -11987,104 +12031,20 @@
                 <a:ea typeface="Calibri" pitchFamily="34" charset="-122"/>
                 <a:cs typeface="Calibri" pitchFamily="34" charset="-120"/>
               </a:rPr>
-              <a:t>Marco bloqueado: a fila ainda monta a mensagem do agente sem o bloco de memória (ajuste pequeno, já diagnosticado).</a:t>
-            </a:r>
-            <a:endParaRPr lang="en-US" sz="1200" dirty="0"/>
-          </a:p>
-        </p:txBody>
-      </p:sp>
-      <p:sp>
-        <p:nvSpPr>
-          <p:cNvPr id="15" name="pend-4"/>
-          <p:cNvSpPr/>
-          <p:nvPr/>
-        </p:nvSpPr>
-        <p:spPr>
-          <a:xfrm>
-            <a:off x="457200" y="3840480"/>
-            <a:ext cx="8229600" cy="566928"/>
-          </a:xfrm>
-          <a:prstGeom prst="roundRect">
-            <a:avLst>
-              <a:gd name="adj" fmla="val 12903"/>
-            </a:avLst>
-          </a:prstGeom>
-          <a:solidFill>
-            <a:schemeClr val="bg2"/>
-          </a:solidFill>
-          <a:ln w="12700">
-            <a:solidFill>
-              <a:schemeClr val="bg2"/>
-            </a:solidFill>
-            <a:prstDash val="solid"/>
-          </a:ln>
-        </p:spPr>
-      </p:sp>
-      <p:sp>
-        <p:nvSpPr>
-          <p:cNvPr id="16" name="Text 14"/>
-          <p:cNvSpPr txBox="1"/>
-          <p:nvPr/>
-        </p:nvSpPr>
-        <p:spPr>
-          <a:xfrm>
-            <a:off x="594360" y="3950208"/>
-            <a:ext cx="548640" cy="347472"/>
-          </a:xfrm>
-          <a:prstGeom prst="rect">
-            <a:avLst/>
-          </a:prstGeom>
-          <a:noFill/>
-          <a:ln/>
-        </p:spPr>
-        <p:txBody>
-          <a:bodyPr wrap="square" lIns="0" tIns="0" rIns="0" bIns="0" rtlCol="0" anchor="t"/>
-          <a:lstStyle/>
-          <a:p>
-            <a:pPr indent="0" marL="0">
-              <a:buNone/>
-            </a:pPr>
-            <a:r>
-              <a:rPr lang="en-US" sz="1600" b="1" dirty="0">
-                <a:solidFill>
-                  <a:schemeClr val="accent3"/>
-                </a:solidFill>
-                <a:latin typeface="Calibri" pitchFamily="34" charset="0"/>
-                <a:ea typeface="Calibri" pitchFamily="34" charset="-122"/>
-                <a:cs typeface="Calibri" pitchFamily="34" charset="-120"/>
-              </a:rPr>
-              <a:t>E7</a:t>
-            </a:r>
-            <a:endParaRPr lang="en-US" sz="1600" dirty="0"/>
-          </a:p>
-        </p:txBody>
-      </p:sp>
-      <p:sp>
-        <p:nvSpPr>
-          <p:cNvPr id="17" name="Text 15"/>
-          <p:cNvSpPr txBox="1"/>
-          <p:nvPr/>
-        </p:nvSpPr>
-        <p:spPr>
-          <a:xfrm>
-            <a:off x="1234440" y="3913632"/>
-            <a:ext cx="7315200" cy="438912"/>
-          </a:xfrm>
-          <a:prstGeom prst="rect">
-            <a:avLst/>
-          </a:prstGeom>
-          <a:noFill/>
-          <a:ln/>
-        </p:spPr>
-        <p:txBody>
-          <a:bodyPr wrap="square" lIns="0" tIns="0" rIns="0" bIns="0" rtlCol="0" anchor="ctr"/>
-          <a:lstStyle/>
-          <a:p>
-            <a:pPr indent="0" marL="0">
-              <a:buNone/>
-            </a:pPr>
-            <a:r>
-              <a:rPr lang="en-US" sz="1200" dirty="0">
+              <a:t>Colocar numa página os componentes de Parar/Retomar e do piloto (prontos e testados, sem tela que os use).</a:t>
+            </a:r>
+            <a:endParaRPr lang="en-US" sz="1400" dirty="0"/>
+          </a:p>
+          <a:p>
+            <a:pPr marL="152400" indent="-152400">
+              <a:spcAft>
+                <a:spcPts val="200"/>
+              </a:spcAft>
+              <a:buSzPct val="100000"/>
+              <a:buChar char="•"/>
+            </a:pPr>
+            <a:r>
+              <a:rPr lang="en-US" sz="950" dirty="0">
                 <a:solidFill>
                   <a:schemeClr val="tx1"/>
                 </a:solidFill>
@@ -12092,9 +12052,51 @@
                 <a:ea typeface="Calibri" pitchFamily="34" charset="-122"/>
                 <a:cs typeface="Calibri" pitchFamily="34" charset="-120"/>
               </a:rPr>
-              <a:t>Marco final (um projeto inteiro sem intervenção) depende do ajuste da E6 e da autorização do teto de gasto.</a:t>
-            </a:r>
-            <a:endParaRPr lang="en-US" sz="1200" dirty="0"/>
+              <a:t>Chamar no caminho real a trilha genérica, os graus de prova e a busca de segredos (prontos e testados, sem chamador).</a:t>
+            </a:r>
+            <a:endParaRPr lang="en-US" sz="1400" dirty="0"/>
+          </a:p>
+          <a:p>
+            <a:pPr marL="152400" indent="-152400">
+              <a:spcAft>
+                <a:spcPts val="200"/>
+              </a:spcAft>
+              <a:buSzPct val="100000"/>
+              <a:buChar char="•"/>
+            </a:pPr>
+            <a:r>
+              <a:rPr lang="en-US" sz="950" dirty="0">
+                <a:solidFill>
+                  <a:schemeClr val="tx1"/>
+                </a:solidFill>
+                <a:latin typeface="Calibri" pitchFamily="34" charset="0"/>
+                <a:ea typeface="Calibri" pitchFamily="34" charset="-122"/>
+                <a:cs typeface="Calibri" pitchFamily="34" charset="-120"/>
+              </a:rPr>
+              <a:t>A fila enviar o bloco de memória ao agente (destrava o marco da E6).</a:t>
+            </a:r>
+            <a:endParaRPr lang="en-US" sz="1400" dirty="0"/>
+          </a:p>
+          <a:p>
+            <a:pPr marL="152400" indent="-152400">
+              <a:spcAft>
+                <a:spcPts val="200"/>
+              </a:spcAft>
+              <a:buSzPct val="100000"/>
+              <a:buChar char="•"/>
+            </a:pPr>
+            <a:r>
+              <a:rPr lang="en-US" sz="950" dirty="0">
+                <a:solidFill>
+                  <a:schemeClr val="tx1"/>
+                </a:solidFill>
+                <a:latin typeface="Calibri" pitchFamily="34" charset="0"/>
+                <a:ea typeface="Calibri" pitchFamily="34" charset="-122"/>
+                <a:cs typeface="Calibri" pitchFamily="34" charset="-120"/>
+              </a:rPr>
+              <a:t>Executar o marco: um projeto inteiro sem intervenção, com teto de gasto autorizado.</a:t>
+            </a:r>
+            <a:endParaRPr lang="en-US" sz="1400" dirty="0"/>
           </a:p>
         </p:txBody>
       </p:sp>

</xml_diff>